<commit_message>
Update deck footer to reflect merged repo path
The title and close slides referred to the pre-merge working folder
gnn-plan-setup. Now that the work is on main under gnn_plan/, point the
footer at the canonical path so the handoff deck matches the repo.
</commit_message>
<xml_diff>
--- a/gnn_plan/artifacts/Augrade GNN Strategy v2.pptx
+++ b/gnn_plan/artifacts/Augrade GNN Strategy v2.pptx
@@ -2319,6 +2319,10 @@
           </a:solidFill>
           <a:ln/>
         </p:spPr>
+        <p:txBody>
+          <a:bodyPr/>
+          <a:p/>
+        </p:txBody>
       </p:sp>
       <p:sp>
         <p:nvSpPr>
@@ -2339,6 +2343,10 @@
           </a:solidFill>
           <a:ln/>
         </p:spPr>
+        <p:txBody>
+          <a:bodyPr/>
+          <a:p/>
+        </p:txBody>
       </p:sp>
       <p:sp>
         <p:nvSpPr>
@@ -2359,6 +2367,10 @@
           </a:solidFill>
           <a:ln/>
         </p:spPr>
+        <p:txBody>
+          <a:bodyPr/>
+          <a:p/>
+        </p:txBody>
       </p:sp>
       <p:sp>
         <p:nvSpPr>
@@ -2379,6 +2391,10 @@
           </a:solidFill>
           <a:ln/>
         </p:spPr>
+        <p:txBody>
+          <a:bodyPr/>
+          <a:p/>
+        </p:txBody>
       </p:sp>
       <p:sp>
         <p:nvSpPr>
@@ -2399,6 +2415,10 @@
           </a:solidFill>
           <a:ln/>
         </p:spPr>
+        <p:txBody>
+          <a:bodyPr/>
+          <a:p/>
+        </p:txBody>
       </p:sp>
       <p:sp>
         <p:nvSpPr>
@@ -2419,6 +2439,10 @@
           </a:solidFill>
           <a:ln/>
         </p:spPr>
+        <p:txBody>
+          <a:bodyPr/>
+          <a:p/>
+        </p:txBody>
       </p:sp>
       <p:sp>
         <p:nvSpPr>
@@ -2439,6 +2463,10 @@
           </a:solidFill>
           <a:ln/>
         </p:spPr>
+        <p:txBody>
+          <a:bodyPr/>
+          <a:p/>
+        </p:txBody>
       </p:sp>
       <p:sp>
         <p:nvSpPr>
@@ -2459,6 +2487,10 @@
           </a:solidFill>
           <a:ln/>
         </p:spPr>
+        <p:txBody>
+          <a:bodyPr/>
+          <a:p/>
+        </p:txBody>
       </p:sp>
       <p:sp>
         <p:nvSpPr>
@@ -2616,6 +2648,10 @@
             <a:prstDash val="solid"/>
           </a:ln>
         </p:spPr>
+        <p:txBody>
+          <a:bodyPr/>
+          <a:p/>
+        </p:txBody>
       </p:sp>
       <p:sp>
         <p:nvSpPr>
@@ -2706,7 +2742,7 @@
                 <a:ea typeface="Consolas" pitchFamily="34" charset="-122"/>
                 <a:cs typeface="Consolas" pitchFamily="34" charset="-120"/>
               </a:rPr>
-              <a:t>DXF_Primitive_to_Polygon · gnn-plan-setup</a:t>
+              <a:t>DXF_Primitive_to_Polygon · gnn_plan/</a:t>
             </a:r>
             <a:endParaRPr lang="en-US" sz="900" dirty="0"/>
           </a:p>
@@ -2805,6 +2841,10 @@
             <a:prstDash val="solid"/>
           </a:ln>
         </p:spPr>
+        <p:txBody>
+          <a:bodyPr/>
+          <a:p/>
+        </p:txBody>
       </p:sp>
       <p:sp>
         <p:nvSpPr>
@@ -2869,6 +2909,10 @@
             <a:prstDash val="solid"/>
           </a:ln>
         </p:spPr>
+        <p:txBody>
+          <a:bodyPr/>
+          <a:p/>
+        </p:txBody>
       </p:sp>
       <p:sp>
         <p:nvSpPr>
@@ -2889,6 +2933,10 @@
           </a:solidFill>
           <a:ln/>
         </p:spPr>
+        <p:txBody>
+          <a:bodyPr/>
+          <a:p/>
+        </p:txBody>
       </p:sp>
       <p:sp>
         <p:nvSpPr>
@@ -3031,6 +3079,10 @@
             <a:prstDash val="solid"/>
           </a:ln>
         </p:spPr>
+        <p:txBody>
+          <a:bodyPr/>
+          <a:p/>
+        </p:txBody>
       </p:sp>
       <p:sp>
         <p:nvSpPr>
@@ -3051,6 +3103,10 @@
           </a:solidFill>
           <a:ln/>
         </p:spPr>
+        <p:txBody>
+          <a:bodyPr/>
+          <a:p/>
+        </p:txBody>
       </p:sp>
       <p:sp>
         <p:nvSpPr>
@@ -3193,6 +3249,10 @@
             <a:prstDash val="solid"/>
           </a:ln>
         </p:spPr>
+        <p:txBody>
+          <a:bodyPr/>
+          <a:p/>
+        </p:txBody>
       </p:sp>
       <p:sp>
         <p:nvSpPr>
@@ -3213,6 +3273,10 @@
           </a:solidFill>
           <a:ln/>
         </p:spPr>
+        <p:txBody>
+          <a:bodyPr/>
+          <a:p/>
+        </p:txBody>
       </p:sp>
       <p:sp>
         <p:nvSpPr>
@@ -3502,6 +3566,10 @@
             <a:prstDash val="solid"/>
           </a:ln>
         </p:spPr>
+        <p:txBody>
+          <a:bodyPr/>
+          <a:p/>
+        </p:txBody>
       </p:sp>
       <p:sp>
         <p:nvSpPr>
@@ -3605,6 +3673,10 @@
             <a:prstDash val="solid"/>
           </a:ln>
         </p:spPr>
+        <p:txBody>
+          <a:bodyPr/>
+          <a:p/>
+        </p:txBody>
       </p:sp>
       <p:sp>
         <p:nvSpPr>
@@ -3625,6 +3697,10 @@
           </a:solidFill>
           <a:ln/>
         </p:spPr>
+        <p:txBody>
+          <a:bodyPr/>
+          <a:p/>
+        </p:txBody>
       </p:sp>
       <p:sp>
         <p:nvSpPr>
@@ -3806,6 +3882,10 @@
             <a:prstDash val="solid"/>
           </a:ln>
         </p:spPr>
+        <p:txBody>
+          <a:bodyPr/>
+          <a:p/>
+        </p:txBody>
       </p:sp>
       <p:sp>
         <p:nvSpPr>
@@ -3826,6 +3906,10 @@
           </a:solidFill>
           <a:ln/>
         </p:spPr>
+        <p:txBody>
+          <a:bodyPr/>
+          <a:p/>
+        </p:txBody>
       </p:sp>
       <p:sp>
         <p:nvSpPr>
@@ -4007,6 +4091,10 @@
             <a:prstDash val="solid"/>
           </a:ln>
         </p:spPr>
+        <p:txBody>
+          <a:bodyPr/>
+          <a:p/>
+        </p:txBody>
       </p:sp>
       <p:sp>
         <p:nvSpPr>
@@ -4027,6 +4115,10 @@
           </a:solidFill>
           <a:ln/>
         </p:spPr>
+        <p:txBody>
+          <a:bodyPr/>
+          <a:p/>
+        </p:txBody>
       </p:sp>
       <p:sp>
         <p:nvSpPr>
@@ -4208,6 +4300,10 @@
             <a:prstDash val="solid"/>
           </a:ln>
         </p:spPr>
+        <p:txBody>
+          <a:bodyPr/>
+          <a:p/>
+        </p:txBody>
       </p:sp>
       <p:sp>
         <p:nvSpPr>
@@ -4228,6 +4324,10 @@
           </a:solidFill>
           <a:ln/>
         </p:spPr>
+        <p:txBody>
+          <a:bodyPr/>
+          <a:p/>
+        </p:txBody>
       </p:sp>
       <p:sp>
         <p:nvSpPr>
@@ -4409,6 +4509,10 @@
             <a:prstDash val="solid"/>
           </a:ln>
         </p:spPr>
+        <p:txBody>
+          <a:bodyPr/>
+          <a:p/>
+        </p:txBody>
       </p:sp>
       <p:sp>
         <p:nvSpPr>
@@ -4429,6 +4533,10 @@
           </a:solidFill>
           <a:ln/>
         </p:spPr>
+        <p:txBody>
+          <a:bodyPr/>
+          <a:p/>
+        </p:txBody>
       </p:sp>
       <p:sp>
         <p:nvSpPr>
@@ -4649,6 +4757,10 @@
             <a:prstDash val="solid"/>
           </a:ln>
         </p:spPr>
+        <p:txBody>
+          <a:bodyPr/>
+          <a:p/>
+        </p:txBody>
       </p:sp>
       <p:sp>
         <p:nvSpPr>
@@ -4669,6 +4781,10 @@
           </a:solidFill>
           <a:ln/>
         </p:spPr>
+        <p:txBody>
+          <a:bodyPr/>
+          <a:p/>
+        </p:txBody>
       </p:sp>
       <p:sp>
         <p:nvSpPr>
@@ -4811,6 +4927,10 @@
             <a:prstDash val="solid"/>
           </a:ln>
         </p:spPr>
+        <p:txBody>
+          <a:bodyPr/>
+          <a:p/>
+        </p:txBody>
       </p:sp>
       <p:sp>
         <p:nvSpPr>
@@ -4831,6 +4951,10 @@
           </a:solidFill>
           <a:ln/>
         </p:spPr>
+        <p:txBody>
+          <a:bodyPr/>
+          <a:p/>
+        </p:txBody>
       </p:sp>
       <p:sp>
         <p:nvSpPr>
@@ -4973,6 +5097,10 @@
             <a:prstDash val="solid"/>
           </a:ln>
         </p:spPr>
+        <p:txBody>
+          <a:bodyPr/>
+          <a:p/>
+        </p:txBody>
       </p:sp>
       <p:sp>
         <p:nvSpPr>
@@ -4993,6 +5121,10 @@
           </a:solidFill>
           <a:ln/>
         </p:spPr>
+        <p:txBody>
+          <a:bodyPr/>
+          <a:p/>
+        </p:txBody>
       </p:sp>
       <p:sp>
         <p:nvSpPr>
@@ -5130,6 +5262,10 @@
           </a:solidFill>
           <a:ln/>
         </p:spPr>
+        <p:txBody>
+          <a:bodyPr/>
+          <a:p/>
+        </p:txBody>
       </p:sp>
       <p:sp>
         <p:nvSpPr>
@@ -5271,6 +5407,1137 @@
 </file>
 
 <file path=ppt/slides/slide12.xml><?xml version="1.0" encoding="utf-8"?>
+<p:sld xmlns:a="http://schemas.openxmlformats.org/drawingml/2006/main" xmlns:r="http://schemas.openxmlformats.org/officeDocument/2006/relationships" xmlns:p="http://schemas.openxmlformats.org/presentationml/2006/main">
+  <p:cSld name="Slide 13">
+    <p:bg>
+      <p:bgPr>
+        <a:solidFill>
+          <a:srgbClr val="F7F5F2"/>
+        </a:solidFill>
+      </p:bgPr>
+    </p:bg>
+    <p:spTree>
+      <p:nvGrpSpPr>
+        <p:cNvPr id="1" name=""/>
+        <p:cNvGrpSpPr/>
+        <p:nvPr/>
+      </p:nvGrpSpPr>
+      <p:grpSpPr>
+        <a:xfrm>
+          <a:off x="0" y="0"/>
+          <a:ext cx="0" cy="0"/>
+          <a:chOff x="0" y="0"/>
+          <a:chExt cx="0" cy="0"/>
+        </a:xfrm>
+      </p:grpSpPr>
+      <p:sp>
+        <p:nvSpPr>
+          <p:cNvPr id="2" name="Text 0"/>
+          <p:cNvSpPr/>
+          <p:nvPr/>
+        </p:nvSpPr>
+        <p:spPr>
+          <a:xfrm>
+            <a:off x="457200" y="365760"/>
+            <a:ext cx="8229600" cy="457200"/>
+          </a:xfrm>
+          <a:prstGeom prst="rect">
+            <a:avLst/>
+          </a:prstGeom>
+          <a:noFill/>
+          <a:ln/>
+        </p:spPr>
+        <p:txBody>
+          <a:bodyPr wrap="square" lIns="0" tIns="0" rIns="0" bIns="0" rtlCol="0" anchor="ctr"/>
+          <a:lstStyle/>
+          <a:p>
+            <a:pPr indent="0" marL="0">
+              <a:buNone/>
+            </a:pPr>
+            <a:r>
+              <a:rPr lang="en-US" sz="1400" spc="1000" kern="0" dirty="0">
+                <a:solidFill>
+                  <a:srgbClr val="4A4F57"/>
+                </a:solidFill>
+                <a:latin typeface="Georgia" pitchFamily="34" charset="0"/>
+                <a:ea typeface="Georgia" pitchFamily="34" charset="-122"/>
+                <a:cs typeface="Georgia" pitchFamily="34" charset="-120"/>
+              </a:rPr>
+              <a:t>Quality loops: make review worth doing</a:t>
+            </a:r>
+            <a:endParaRPr lang="en-US" sz="1400" dirty="0"/>
+          </a:p>
+        </p:txBody>
+      </p:sp>
+      <p:sp>
+        <p:nvSpPr>
+          <p:cNvPr id="3" name="Shape 1"/>
+          <p:cNvSpPr/>
+          <p:nvPr/>
+        </p:nvSpPr>
+        <p:spPr>
+          <a:xfrm>
+            <a:off x="457200" y="777240"/>
+            <a:ext cx="914400" cy="0"/>
+          </a:xfrm>
+          <a:prstGeom prst="line">
+            <a:avLst/>
+          </a:prstGeom>
+          <a:noFill/>
+          <a:ln w="19050">
+            <a:solidFill>
+              <a:srgbClr val="C8761A"/>
+            </a:solidFill>
+            <a:prstDash val="solid"/>
+          </a:ln>
+        </p:spPr>
+        <p:txBody>
+          <a:bodyPr/>
+          <a:p/>
+        </p:txBody>
+      </p:sp>
+      <p:sp>
+        <p:nvSpPr>
+          <p:cNvPr id="4" name="Text 2"/>
+          <p:cNvSpPr/>
+          <p:nvPr/>
+        </p:nvSpPr>
+        <p:spPr>
+          <a:xfrm>
+            <a:off x="457200" y="914400"/>
+            <a:ext cx="8229600" cy="457200"/>
+          </a:xfrm>
+          <a:prstGeom prst="rect">
+            <a:avLst/>
+          </a:prstGeom>
+          <a:noFill/>
+          <a:ln/>
+        </p:spPr>
+        <p:txBody>
+          <a:bodyPr wrap="square" lIns="0" tIns="0" rIns="0" bIns="0" rtlCol="0" anchor="ctr"/>
+          <a:lstStyle/>
+          <a:p>
+            <a:pPr indent="0" marL="0">
+              <a:buNone/>
+            </a:pPr>
+            <a:r>
+              <a:rPr lang="en-US" sz="1700" b="1" dirty="0">
+                <a:solidFill>
+                  <a:srgbClr val="1B1D22"/>
+                </a:solidFill>
+                <a:latin typeface="Georgia" pitchFamily="34" charset="0"/>
+                <a:ea typeface="Georgia" pitchFamily="34" charset="-122"/>
+                <a:cs typeface="Georgia" pitchFamily="34" charset="-120"/>
+              </a:rPr>
+              <a:t>The human loop is not a tax. It is the product surface where expertise becomes data.</a:t>
+            </a:r>
+            <a:endParaRPr lang="en-US" sz="1700" dirty="0"/>
+          </a:p>
+        </p:txBody>
+      </p:sp>
+      <p:sp>
+        <p:nvSpPr>
+          <p:cNvPr id="5" name="Shape 3"/>
+          <p:cNvSpPr/>
+          <p:nvPr/>
+        </p:nvSpPr>
+        <p:spPr>
+          <a:xfrm>
+            <a:off x="502920" y="1627632"/>
+            <a:ext cx="2697480" cy="2926080"/>
+          </a:xfrm>
+          <a:prstGeom prst="rect">
+            <a:avLst/>
+          </a:prstGeom>
+          <a:solidFill>
+            <a:srgbClr val="FFFFFF"/>
+          </a:solidFill>
+          <a:ln w="6350">
+            <a:solidFill>
+              <a:srgbClr val="C9C2B7"/>
+            </a:solidFill>
+            <a:prstDash val="solid"/>
+          </a:ln>
+        </p:spPr>
+        <p:txBody>
+          <a:bodyPr/>
+          <a:p/>
+        </p:txBody>
+      </p:sp>
+      <p:sp>
+        <p:nvSpPr>
+          <p:cNvPr id="6" name="Shape 4"/>
+          <p:cNvSpPr/>
+          <p:nvPr/>
+        </p:nvSpPr>
+        <p:spPr>
+          <a:xfrm>
+            <a:off x="502920" y="1627632"/>
+            <a:ext cx="73152" cy="2926080"/>
+          </a:xfrm>
+          <a:prstGeom prst="rect">
+            <a:avLst/>
+          </a:prstGeom>
+          <a:solidFill>
+            <a:srgbClr val="4A4F57"/>
+          </a:solidFill>
+          <a:ln/>
+        </p:spPr>
+        <p:txBody>
+          <a:bodyPr/>
+          <a:p/>
+        </p:txBody>
+      </p:sp>
+      <p:sp>
+        <p:nvSpPr>
+          <p:cNvPr id="7" name="Text 5"/>
+          <p:cNvSpPr/>
+          <p:nvPr/>
+        </p:nvSpPr>
+        <p:spPr>
+          <a:xfrm>
+            <a:off x="777240" y="1792224"/>
+            <a:ext cx="2331720" cy="292608"/>
+          </a:xfrm>
+          <a:prstGeom prst="rect">
+            <a:avLst/>
+          </a:prstGeom>
+          <a:noFill/>
+          <a:ln/>
+        </p:spPr>
+        <p:txBody>
+          <a:bodyPr wrap="square" lIns="0" tIns="0" rIns="0" bIns="0" rtlCol="0" anchor="ctr"/>
+          <a:lstStyle/>
+          <a:p>
+            <a:pPr indent="0" marL="0">
+              <a:buNone/>
+            </a:pPr>
+            <a:r>
+              <a:rPr lang="en-US" sz="1400" b="1" dirty="0">
+                <a:solidFill>
+                  <a:srgbClr val="1B1D22"/>
+                </a:solidFill>
+                <a:latin typeface="Georgia" pitchFamily="34" charset="0"/>
+                <a:ea typeface="Georgia" pitchFamily="34" charset="-122"/>
+                <a:cs typeface="Georgia" pitchFamily="34" charset="-120"/>
+              </a:rPr>
+              <a:t>Operator sees</a:t>
+            </a:r>
+            <a:endParaRPr lang="en-US" sz="1400" dirty="0"/>
+          </a:p>
+        </p:txBody>
+      </p:sp>
+      <p:sp>
+        <p:nvSpPr>
+          <p:cNvPr id="8" name="Text 6"/>
+          <p:cNvSpPr/>
+          <p:nvPr/>
+        </p:nvSpPr>
+        <p:spPr>
+          <a:xfrm>
+            <a:off x="777240" y="2084832"/>
+            <a:ext cx="2331720" cy="219456"/>
+          </a:xfrm>
+          <a:prstGeom prst="rect">
+            <a:avLst/>
+          </a:prstGeom>
+          <a:noFill/>
+          <a:ln/>
+        </p:spPr>
+        <p:txBody>
+          <a:bodyPr wrap="square" lIns="0" tIns="0" rIns="0" bIns="0" rtlCol="0" anchor="ctr"/>
+          <a:lstStyle/>
+          <a:p>
+            <a:pPr indent="0" marL="0">
+              <a:buNone/>
+            </a:pPr>
+            <a:r>
+              <a:rPr lang="en-US" sz="950" i="1" dirty="0">
+                <a:solidFill>
+                  <a:srgbClr val="4A4F57"/>
+                </a:solidFill>
+                <a:latin typeface="Calibri" pitchFamily="34" charset="0"/>
+                <a:ea typeface="Calibri" pitchFamily="34" charset="-122"/>
+                <a:cs typeface="Calibri" pitchFamily="34" charset="-120"/>
+              </a:rPr>
+              <a:t>in the review surface</a:t>
+            </a:r>
+            <a:endParaRPr lang="en-US" sz="950" dirty="0"/>
+          </a:p>
+        </p:txBody>
+      </p:sp>
+      <p:sp>
+        <p:nvSpPr>
+          <p:cNvPr id="9" name="Text 7"/>
+          <p:cNvSpPr/>
+          <p:nvPr/>
+        </p:nvSpPr>
+        <p:spPr>
+          <a:xfrm>
+            <a:off x="777240" y="2359152"/>
+            <a:ext cx="2286000" cy="2103120"/>
+          </a:xfrm>
+          <a:prstGeom prst="rect">
+            <a:avLst/>
+          </a:prstGeom>
+          <a:noFill/>
+          <a:ln/>
+        </p:spPr>
+        <p:txBody>
+          <a:bodyPr wrap="square" lIns="0" tIns="0" rIns="0" bIns="0" rtlCol="0" anchor="t"/>
+          <a:lstStyle/>
+          <a:p>
+            <a:pPr indent="0" marL="0">
+              <a:spcAft>
+                <a:spcPts val="400"/>
+              </a:spcAft>
+              <a:buNone/>
+            </a:pPr>
+            <a:r>
+              <a:rPr lang="en-US" sz="1000" dirty="0">
+                <a:solidFill>
+                  <a:srgbClr val="4A4F57"/>
+                </a:solidFill>
+                <a:latin typeface="Calibri" pitchFamily="34" charset="0"/>
+                <a:ea typeface="Calibri" pitchFamily="34" charset="-122"/>
+                <a:cs typeface="Calibri" pitchFamily="34" charset="-120"/>
+              </a:rPr>
+              <a:t>before / after overlay</a:t>
+            </a:r>
+            <a:endParaRPr lang="en-US" sz="1000" dirty="0"/>
+          </a:p>
+          <a:p>
+            <a:pPr indent="0" marL="0">
+              <a:spcAft>
+                <a:spcPts val="400"/>
+              </a:spcAft>
+              <a:buNone/>
+            </a:pPr>
+            <a:r>
+              <a:rPr lang="en-US" sz="1000" dirty="0">
+                <a:solidFill>
+                  <a:srgbClr val="4A4F57"/>
+                </a:solidFill>
+                <a:latin typeface="Calibri" pitchFamily="34" charset="0"/>
+                <a:ea typeface="Calibri" pitchFamily="34" charset="-122"/>
+                <a:cs typeface="Calibri" pitchFamily="34" charset="-120"/>
+              </a:rPr>
+              <a:t>model hypothesis</a:t>
+            </a:r>
+            <a:endParaRPr lang="en-US" sz="1000" dirty="0"/>
+          </a:p>
+          <a:p>
+            <a:pPr indent="0" marL="0">
+              <a:spcAft>
+                <a:spcPts val="400"/>
+              </a:spcAft>
+              <a:buNone/>
+            </a:pPr>
+            <a:r>
+              <a:rPr lang="en-US" sz="1000" dirty="0">
+                <a:solidFill>
+                  <a:srgbClr val="4A4F57"/>
+                </a:solidFill>
+                <a:latin typeface="Calibri" pitchFamily="34" charset="0"/>
+                <a:ea typeface="Calibri" pitchFamily="34" charset="-122"/>
+                <a:cs typeface="Calibri" pitchFamily="34" charset="-120"/>
+              </a:rPr>
+              <a:t>validator residual</a:t>
+            </a:r>
+            <a:endParaRPr lang="en-US" sz="1000" dirty="0"/>
+          </a:p>
+          <a:p>
+            <a:pPr indent="0" marL="0">
+              <a:spcAft>
+                <a:spcPts val="400"/>
+              </a:spcAft>
+              <a:buNone/>
+            </a:pPr>
+            <a:r>
+              <a:rPr lang="en-US" sz="1000" dirty="0">
+                <a:solidFill>
+                  <a:srgbClr val="4A4F57"/>
+                </a:solidFill>
+                <a:latin typeface="Calibri" pitchFamily="34" charset="0"/>
+                <a:ea typeface="Calibri" pitchFamily="34" charset="-122"/>
+                <a:cs typeface="Calibri" pitchFamily="34" charset="-120"/>
+              </a:rPr>
+              <a:t>similar past cases</a:t>
+            </a:r>
+            <a:endParaRPr lang="en-US" sz="1000" dirty="0"/>
+          </a:p>
+          <a:p>
+            <a:pPr indent="0" marL="0">
+              <a:spcAft>
+                <a:spcPts val="400"/>
+              </a:spcAft>
+              <a:buNone/>
+            </a:pPr>
+            <a:r>
+              <a:rPr lang="en-US" sz="1000" dirty="0">
+                <a:solidFill>
+                  <a:srgbClr val="4A4F57"/>
+                </a:solidFill>
+                <a:latin typeface="Calibri" pitchFamily="34" charset="0"/>
+                <a:ea typeface="Calibri" pitchFamily="34" charset="-122"/>
+                <a:cs typeface="Calibri" pitchFamily="34" charset="-120"/>
+              </a:rPr>
+              <a:t>one-click approve / reject / repair</a:t>
+            </a:r>
+            <a:endParaRPr lang="en-US" sz="1000" dirty="0"/>
+          </a:p>
+          <a:p>
+            <a:pPr indent="0" marL="0">
+              <a:spcAft>
+                <a:spcPts val="400"/>
+              </a:spcAft>
+              <a:buNone/>
+            </a:pPr>
+            <a:r>
+              <a:rPr lang="en-US" sz="1000" dirty="0">
+                <a:solidFill>
+                  <a:srgbClr val="4A4F57"/>
+                </a:solidFill>
+                <a:latin typeface="Calibri" pitchFamily="34" charset="0"/>
+                <a:ea typeface="Calibri" pitchFamily="34" charset="-122"/>
+                <a:cs typeface="Calibri" pitchFamily="34" charset="-120"/>
+              </a:rPr>
+              <a:t>why-it-matters explanation</a:t>
+            </a:r>
+            <a:endParaRPr lang="en-US" sz="1000" dirty="0"/>
+          </a:p>
+        </p:txBody>
+      </p:sp>
+      <p:sp>
+        <p:nvSpPr>
+          <p:cNvPr id="10" name="Shape 8"/>
+          <p:cNvSpPr/>
+          <p:nvPr/>
+        </p:nvSpPr>
+        <p:spPr>
+          <a:xfrm>
+            <a:off x="3291840" y="1627632"/>
+            <a:ext cx="2697480" cy="2926080"/>
+          </a:xfrm>
+          <a:prstGeom prst="rect">
+            <a:avLst/>
+          </a:prstGeom>
+          <a:solidFill>
+            <a:srgbClr val="FFFFFF"/>
+          </a:solidFill>
+          <a:ln w="6350">
+            <a:solidFill>
+              <a:srgbClr val="C9C2B7"/>
+            </a:solidFill>
+            <a:prstDash val="solid"/>
+          </a:ln>
+        </p:spPr>
+        <p:txBody>
+          <a:bodyPr/>
+          <a:p/>
+        </p:txBody>
+      </p:sp>
+      <p:sp>
+        <p:nvSpPr>
+          <p:cNvPr id="11" name="Shape 9"/>
+          <p:cNvSpPr/>
+          <p:nvPr/>
+        </p:nvSpPr>
+        <p:spPr>
+          <a:xfrm>
+            <a:off x="3291840" y="1627632"/>
+            <a:ext cx="73152" cy="2926080"/>
+          </a:xfrm>
+          <a:prstGeom prst="rect">
+            <a:avLst/>
+          </a:prstGeom>
+          <a:solidFill>
+            <a:srgbClr val="C8761A"/>
+          </a:solidFill>
+          <a:ln/>
+        </p:spPr>
+        <p:txBody>
+          <a:bodyPr/>
+          <a:p/>
+        </p:txBody>
+      </p:sp>
+      <p:sp>
+        <p:nvSpPr>
+          <p:cNvPr id="12" name="Text 10"/>
+          <p:cNvSpPr/>
+          <p:nvPr/>
+        </p:nvSpPr>
+        <p:spPr>
+          <a:xfrm>
+            <a:off x="3566160" y="1792224"/>
+            <a:ext cx="2331720" cy="292608"/>
+          </a:xfrm>
+          <a:prstGeom prst="rect">
+            <a:avLst/>
+          </a:prstGeom>
+          <a:noFill/>
+          <a:ln/>
+        </p:spPr>
+        <p:txBody>
+          <a:bodyPr wrap="square" lIns="0" tIns="0" rIns="0" bIns="0" rtlCol="0" anchor="ctr"/>
+          <a:lstStyle/>
+          <a:p>
+            <a:pPr indent="0" marL="0">
+              <a:buNone/>
+            </a:pPr>
+            <a:r>
+              <a:rPr lang="en-US" sz="1400" b="1" dirty="0">
+                <a:solidFill>
+                  <a:srgbClr val="1B1D22"/>
+                </a:solidFill>
+                <a:latin typeface="Georgia" pitchFamily="34" charset="0"/>
+                <a:ea typeface="Georgia" pitchFamily="34" charset="-122"/>
+                <a:cs typeface="Georgia" pitchFamily="34" charset="-120"/>
+              </a:rPr>
+              <a:t>System captures</a:t>
+            </a:r>
+            <a:endParaRPr lang="en-US" sz="1400" dirty="0"/>
+          </a:p>
+        </p:txBody>
+      </p:sp>
+      <p:sp>
+        <p:nvSpPr>
+          <p:cNvPr id="13" name="Text 11"/>
+          <p:cNvSpPr/>
+          <p:nvPr/>
+        </p:nvSpPr>
+        <p:spPr>
+          <a:xfrm>
+            <a:off x="3566160" y="2084832"/>
+            <a:ext cx="2331720" cy="219456"/>
+          </a:xfrm>
+          <a:prstGeom prst="rect">
+            <a:avLst/>
+          </a:prstGeom>
+          <a:noFill/>
+          <a:ln/>
+        </p:spPr>
+        <p:txBody>
+          <a:bodyPr wrap="square" lIns="0" tIns="0" rIns="0" bIns="0" rtlCol="0" anchor="ctr"/>
+          <a:lstStyle/>
+          <a:p>
+            <a:pPr indent="0" marL="0">
+              <a:buNone/>
+            </a:pPr>
+            <a:r>
+              <a:rPr lang="en-US" sz="950" i="1" dirty="0">
+                <a:solidFill>
+                  <a:srgbClr val="4A4F57"/>
+                </a:solidFill>
+                <a:latin typeface="Calibri" pitchFamily="34" charset="0"/>
+                <a:ea typeface="Calibri" pitchFamily="34" charset="-122"/>
+                <a:cs typeface="Calibri" pitchFamily="34" charset="-120"/>
+              </a:rPr>
+              <a:t>into persistent memory</a:t>
+            </a:r>
+            <a:endParaRPr lang="en-US" sz="950" dirty="0"/>
+          </a:p>
+        </p:txBody>
+      </p:sp>
+      <p:sp>
+        <p:nvSpPr>
+          <p:cNvPr id="14" name="Text 12"/>
+          <p:cNvSpPr/>
+          <p:nvPr/>
+        </p:nvSpPr>
+        <p:spPr>
+          <a:xfrm>
+            <a:off x="3566160" y="2359152"/>
+            <a:ext cx="2286000" cy="2103120"/>
+          </a:xfrm>
+          <a:prstGeom prst="rect">
+            <a:avLst/>
+          </a:prstGeom>
+          <a:noFill/>
+          <a:ln/>
+        </p:spPr>
+        <p:txBody>
+          <a:bodyPr wrap="square" lIns="0" tIns="0" rIns="0" bIns="0" rtlCol="0" anchor="t"/>
+          <a:lstStyle/>
+          <a:p>
+            <a:pPr indent="0" marL="0">
+              <a:spcAft>
+                <a:spcPts val="400"/>
+              </a:spcAft>
+              <a:buNone/>
+            </a:pPr>
+            <a:r>
+              <a:rPr lang="en-US" sz="1000" dirty="0">
+                <a:solidFill>
+                  <a:srgbClr val="4A4F57"/>
+                </a:solidFill>
+                <a:latin typeface="Calibri" pitchFamily="34" charset="0"/>
+                <a:ea typeface="Calibri" pitchFamily="34" charset="-122"/>
+                <a:cs typeface="Calibri" pitchFamily="34" charset="-120"/>
+              </a:rPr>
+              <a:t>label / preference</a:t>
+            </a:r>
+            <a:endParaRPr lang="en-US" sz="1000" dirty="0"/>
+          </a:p>
+          <a:p>
+            <a:pPr indent="0" marL="0">
+              <a:spcAft>
+                <a:spcPts val="400"/>
+              </a:spcAft>
+              <a:buNone/>
+            </a:pPr>
+            <a:r>
+              <a:rPr lang="en-US" sz="1000" dirty="0">
+                <a:solidFill>
+                  <a:srgbClr val="4A4F57"/>
+                </a:solidFill>
+                <a:latin typeface="Calibri" pitchFamily="34" charset="0"/>
+                <a:ea typeface="Calibri" pitchFamily="34" charset="-122"/>
+                <a:cs typeface="Calibri" pitchFamily="34" charset="-120"/>
+              </a:rPr>
+              <a:t>correction trace</a:t>
+            </a:r>
+            <a:endParaRPr lang="en-US" sz="1000" dirty="0"/>
+          </a:p>
+          <a:p>
+            <a:pPr indent="0" marL="0">
+              <a:spcAft>
+                <a:spcPts val="400"/>
+              </a:spcAft>
+              <a:buNone/>
+            </a:pPr>
+            <a:r>
+              <a:rPr lang="en-US" sz="1000" dirty="0">
+                <a:solidFill>
+                  <a:srgbClr val="4A4F57"/>
+                </a:solidFill>
+                <a:latin typeface="Calibri" pitchFamily="34" charset="0"/>
+                <a:ea typeface="Calibri" pitchFamily="34" charset="-122"/>
+                <a:cs typeface="Calibri" pitchFamily="34" charset="-120"/>
+              </a:rPr>
+              <a:t>edit delta</a:t>
+            </a:r>
+            <a:endParaRPr lang="en-US" sz="1000" dirty="0"/>
+          </a:p>
+          <a:p>
+            <a:pPr indent="0" marL="0">
+              <a:spcAft>
+                <a:spcPts val="400"/>
+              </a:spcAft>
+              <a:buNone/>
+            </a:pPr>
+            <a:r>
+              <a:rPr lang="en-US" sz="1000" dirty="0">
+                <a:solidFill>
+                  <a:srgbClr val="4A4F57"/>
+                </a:solidFill>
+                <a:latin typeface="Calibri" pitchFamily="34" charset="0"/>
+                <a:ea typeface="Calibri" pitchFamily="34" charset="-122"/>
+                <a:cs typeface="Calibri" pitchFamily="34" charset="-120"/>
+              </a:rPr>
+              <a:t>validator before / after</a:t>
+            </a:r>
+            <a:endParaRPr lang="en-US" sz="1000" dirty="0"/>
+          </a:p>
+          <a:p>
+            <a:pPr indent="0" marL="0">
+              <a:spcAft>
+                <a:spcPts val="400"/>
+              </a:spcAft>
+              <a:buNone/>
+            </a:pPr>
+            <a:r>
+              <a:rPr lang="en-US" sz="1000" dirty="0">
+                <a:solidFill>
+                  <a:srgbClr val="4A4F57"/>
+                </a:solidFill>
+                <a:latin typeface="Calibri" pitchFamily="34" charset="0"/>
+                <a:ea typeface="Calibri" pitchFamily="34" charset="-122"/>
+                <a:cs typeface="Calibri" pitchFamily="34" charset="-120"/>
+              </a:rPr>
+              <a:t>time-to-fix</a:t>
+            </a:r>
+            <a:endParaRPr lang="en-US" sz="1000" dirty="0"/>
+          </a:p>
+          <a:p>
+            <a:pPr indent="0" marL="0">
+              <a:spcAft>
+                <a:spcPts val="400"/>
+              </a:spcAft>
+              <a:buNone/>
+            </a:pPr>
+            <a:r>
+              <a:rPr lang="en-US" sz="1000" dirty="0">
+                <a:solidFill>
+                  <a:srgbClr val="4A4F57"/>
+                </a:solidFill>
+                <a:latin typeface="Calibri" pitchFamily="34" charset="0"/>
+                <a:ea typeface="Calibri" pitchFamily="34" charset="-122"/>
+                <a:cs typeface="Calibri" pitchFamily="34" charset="-120"/>
+              </a:rPr>
+              <a:t>confidence shift</a:t>
+            </a:r>
+            <a:endParaRPr lang="en-US" sz="1000" dirty="0"/>
+          </a:p>
+          <a:p>
+            <a:pPr indent="0" marL="0">
+              <a:spcAft>
+                <a:spcPts val="400"/>
+              </a:spcAft>
+              <a:buNone/>
+            </a:pPr>
+            <a:r>
+              <a:rPr lang="en-US" sz="1000" dirty="0">
+                <a:solidFill>
+                  <a:srgbClr val="4A4F57"/>
+                </a:solidFill>
+                <a:latin typeface="Calibri" pitchFamily="34" charset="0"/>
+                <a:ea typeface="Calibri" pitchFamily="34" charset="-122"/>
+                <a:cs typeface="Calibri" pitchFamily="34" charset="-120"/>
+              </a:rPr>
+              <a:t>motif / rule candidate</a:t>
+            </a:r>
+            <a:endParaRPr lang="en-US" sz="1000" dirty="0"/>
+          </a:p>
+        </p:txBody>
+      </p:sp>
+      <p:sp>
+        <p:nvSpPr>
+          <p:cNvPr id="15" name="Shape 13"/>
+          <p:cNvSpPr/>
+          <p:nvPr/>
+        </p:nvSpPr>
+        <p:spPr>
+          <a:xfrm>
+            <a:off x="6080760" y="1627632"/>
+            <a:ext cx="2697480" cy="2926080"/>
+          </a:xfrm>
+          <a:prstGeom prst="rect">
+            <a:avLst/>
+          </a:prstGeom>
+          <a:solidFill>
+            <a:srgbClr val="FFFFFF"/>
+          </a:solidFill>
+          <a:ln w="6350">
+            <a:solidFill>
+              <a:srgbClr val="C9C2B7"/>
+            </a:solidFill>
+            <a:prstDash val="solid"/>
+          </a:ln>
+        </p:spPr>
+        <p:txBody>
+          <a:bodyPr/>
+          <a:p/>
+        </p:txBody>
+      </p:sp>
+      <p:sp>
+        <p:nvSpPr>
+          <p:cNvPr id="16" name="Shape 14"/>
+          <p:cNvSpPr/>
+          <p:nvPr/>
+        </p:nvSpPr>
+        <p:spPr>
+          <a:xfrm>
+            <a:off x="6080760" y="1627632"/>
+            <a:ext cx="73152" cy="2926080"/>
+          </a:xfrm>
+          <a:prstGeom prst="rect">
+            <a:avLst/>
+          </a:prstGeom>
+          <a:solidFill>
+            <a:srgbClr val="3F6B4A"/>
+          </a:solidFill>
+          <a:ln/>
+        </p:spPr>
+        <p:txBody>
+          <a:bodyPr/>
+          <a:p/>
+        </p:txBody>
+      </p:sp>
+      <p:sp>
+        <p:nvSpPr>
+          <p:cNvPr id="17" name="Text 15"/>
+          <p:cNvSpPr/>
+          <p:nvPr/>
+        </p:nvSpPr>
+        <p:spPr>
+          <a:xfrm>
+            <a:off x="6355080" y="1792224"/>
+            <a:ext cx="2331720" cy="292608"/>
+          </a:xfrm>
+          <a:prstGeom prst="rect">
+            <a:avLst/>
+          </a:prstGeom>
+          <a:noFill/>
+          <a:ln/>
+        </p:spPr>
+        <p:txBody>
+          <a:bodyPr wrap="square" lIns="0" tIns="0" rIns="0" bIns="0" rtlCol="0" anchor="ctr"/>
+          <a:lstStyle/>
+          <a:p>
+            <a:pPr indent="0" marL="0">
+              <a:buNone/>
+            </a:pPr>
+            <a:r>
+              <a:rPr lang="en-US" sz="1400" b="1" dirty="0">
+                <a:solidFill>
+                  <a:srgbClr val="1B1D22"/>
+                </a:solidFill>
+                <a:latin typeface="Georgia" pitchFamily="34" charset="0"/>
+                <a:ea typeface="Georgia" pitchFamily="34" charset="-122"/>
+                <a:cs typeface="Georgia" pitchFamily="34" charset="-120"/>
+              </a:rPr>
+              <a:t>Product improves</a:t>
+            </a:r>
+            <a:endParaRPr lang="en-US" sz="1400" dirty="0"/>
+          </a:p>
+        </p:txBody>
+      </p:sp>
+      <p:sp>
+        <p:nvSpPr>
+          <p:cNvPr id="18" name="Text 16"/>
+          <p:cNvSpPr/>
+          <p:nvPr/>
+        </p:nvSpPr>
+        <p:spPr>
+          <a:xfrm>
+            <a:off x="6355080" y="2084832"/>
+            <a:ext cx="2331720" cy="219456"/>
+          </a:xfrm>
+          <a:prstGeom prst="rect">
+            <a:avLst/>
+          </a:prstGeom>
+          <a:noFill/>
+          <a:ln/>
+        </p:spPr>
+        <p:txBody>
+          <a:bodyPr wrap="square" lIns="0" tIns="0" rIns="0" bIns="0" rtlCol="0" anchor="ctr"/>
+          <a:lstStyle/>
+          <a:p>
+            <a:pPr indent="0" marL="0">
+              <a:buNone/>
+            </a:pPr>
+            <a:r>
+              <a:rPr lang="en-US" sz="950" i="1" dirty="0">
+                <a:solidFill>
+                  <a:srgbClr val="4A4F57"/>
+                </a:solidFill>
+                <a:latin typeface="Calibri" pitchFamily="34" charset="0"/>
+                <a:ea typeface="Calibri" pitchFamily="34" charset="-122"/>
+                <a:cs typeface="Calibri" pitchFamily="34" charset="-120"/>
+              </a:rPr>
+              <a:t>every loop iteration</a:t>
+            </a:r>
+            <a:endParaRPr lang="en-US" sz="950" dirty="0"/>
+          </a:p>
+        </p:txBody>
+      </p:sp>
+      <p:sp>
+        <p:nvSpPr>
+          <p:cNvPr id="19" name="Text 17"/>
+          <p:cNvSpPr/>
+          <p:nvPr/>
+        </p:nvSpPr>
+        <p:spPr>
+          <a:xfrm>
+            <a:off x="6355080" y="2359152"/>
+            <a:ext cx="2286000" cy="2103120"/>
+          </a:xfrm>
+          <a:prstGeom prst="rect">
+            <a:avLst/>
+          </a:prstGeom>
+          <a:noFill/>
+          <a:ln/>
+        </p:spPr>
+        <p:txBody>
+          <a:bodyPr wrap="square" lIns="0" tIns="0" rIns="0" bIns="0" rtlCol="0" anchor="t"/>
+          <a:lstStyle/>
+          <a:p>
+            <a:pPr indent="0" marL="0">
+              <a:spcAft>
+                <a:spcPts val="400"/>
+              </a:spcAft>
+              <a:buNone/>
+            </a:pPr>
+            <a:r>
+              <a:rPr lang="en-US" sz="1000" dirty="0">
+                <a:solidFill>
+                  <a:srgbClr val="4A4F57"/>
+                </a:solidFill>
+                <a:latin typeface="Calibri" pitchFamily="34" charset="0"/>
+                <a:ea typeface="Calibri" pitchFamily="34" charset="-122"/>
+                <a:cs typeface="Calibri" pitchFamily="34" charset="-120"/>
+              </a:rPr>
+              <a:t>fewer repeated errors</a:t>
+            </a:r>
+            <a:endParaRPr lang="en-US" sz="1000" dirty="0"/>
+          </a:p>
+          <a:p>
+            <a:pPr indent="0" marL="0">
+              <a:spcAft>
+                <a:spcPts val="400"/>
+              </a:spcAft>
+              <a:buNone/>
+            </a:pPr>
+            <a:r>
+              <a:rPr lang="en-US" sz="1000" dirty="0">
+                <a:solidFill>
+                  <a:srgbClr val="4A4F57"/>
+                </a:solidFill>
+                <a:latin typeface="Calibri" pitchFamily="34" charset="0"/>
+                <a:ea typeface="Calibri" pitchFamily="34" charset="-122"/>
+                <a:cs typeface="Calibri" pitchFamily="34" charset="-120"/>
+              </a:rPr>
+              <a:t>better retrieval</a:t>
+            </a:r>
+            <a:endParaRPr lang="en-US" sz="1000" dirty="0"/>
+          </a:p>
+          <a:p>
+            <a:pPr indent="0" marL="0">
+              <a:spcAft>
+                <a:spcPts val="400"/>
+              </a:spcAft>
+              <a:buNone/>
+            </a:pPr>
+            <a:r>
+              <a:rPr lang="en-US" sz="1000" dirty="0">
+                <a:solidFill>
+                  <a:srgbClr val="4A4F57"/>
+                </a:solidFill>
+                <a:latin typeface="Calibri" pitchFamily="34" charset="0"/>
+                <a:ea typeface="Calibri" pitchFamily="34" charset="-122"/>
+                <a:cs typeface="Calibri" pitchFamily="34" charset="-120"/>
+              </a:rPr>
+              <a:t>tighter conformal bands</a:t>
+            </a:r>
+            <a:endParaRPr lang="en-US" sz="1000" dirty="0"/>
+          </a:p>
+          <a:p>
+            <a:pPr indent="0" marL="0">
+              <a:spcAft>
+                <a:spcPts val="400"/>
+              </a:spcAft>
+              <a:buNone/>
+            </a:pPr>
+            <a:r>
+              <a:rPr lang="en-US" sz="1000" dirty="0">
+                <a:solidFill>
+                  <a:srgbClr val="4A4F57"/>
+                </a:solidFill>
+                <a:latin typeface="Calibri" pitchFamily="34" charset="0"/>
+                <a:ea typeface="Calibri" pitchFamily="34" charset="-122"/>
+                <a:cs typeface="Calibri" pitchFamily="34" charset="-120"/>
+              </a:rPr>
+              <a:t>stronger prototype memory</a:t>
+            </a:r>
+            <a:endParaRPr lang="en-US" sz="1000" dirty="0"/>
+          </a:p>
+          <a:p>
+            <a:pPr indent="0" marL="0">
+              <a:spcAft>
+                <a:spcPts val="400"/>
+              </a:spcAft>
+              <a:buNone/>
+            </a:pPr>
+            <a:r>
+              <a:rPr lang="en-US" sz="1000" dirty="0">
+                <a:solidFill>
+                  <a:srgbClr val="4A4F57"/>
+                </a:solidFill>
+                <a:latin typeface="Calibri" pitchFamily="34" charset="0"/>
+                <a:ea typeface="Calibri" pitchFamily="34" charset="-122"/>
+                <a:cs typeface="Calibri" pitchFamily="34" charset="-120"/>
+              </a:rPr>
+              <a:t>new deterministic rules</a:t>
+            </a:r>
+            <a:endParaRPr lang="en-US" sz="1000" dirty="0"/>
+          </a:p>
+          <a:p>
+            <a:pPr indent="0" marL="0">
+              <a:spcAft>
+                <a:spcPts val="400"/>
+              </a:spcAft>
+              <a:buNone/>
+            </a:pPr>
+            <a:r>
+              <a:rPr lang="en-US" sz="1000" dirty="0">
+                <a:solidFill>
+                  <a:srgbClr val="4A4F57"/>
+                </a:solidFill>
+                <a:latin typeface="Calibri" pitchFamily="34" charset="0"/>
+                <a:ea typeface="Calibri" pitchFamily="34" charset="-122"/>
+                <a:cs typeface="Calibri" pitchFamily="34" charset="-120"/>
+              </a:rPr>
+              <a:t>safer auto-apply threshold</a:t>
+            </a:r>
+            <a:endParaRPr lang="en-US" sz="1000" dirty="0"/>
+          </a:p>
+        </p:txBody>
+      </p:sp>
+      <p:sp>
+        <p:nvSpPr>
+          <p:cNvPr id="20" name="Shape 18"/>
+          <p:cNvSpPr/>
+          <p:nvPr/>
+        </p:nvSpPr>
+        <p:spPr>
+          <a:xfrm>
+            <a:off x="502920" y="4555000"/>
+            <a:ext cx="8229600" cy="291320"/>
+          </a:xfrm>
+          <a:prstGeom prst="rect">
+            <a:avLst/>
+          </a:prstGeom>
+          <a:solidFill>
+            <a:srgbClr val="1B1D22"/>
+          </a:solidFill>
+          <a:ln/>
+        </p:spPr>
+        <p:txBody>
+          <a:bodyPr/>
+          <a:p/>
+        </p:txBody>
+      </p:sp>
+      <p:sp>
+        <p:nvSpPr>
+          <p:cNvPr id="21" name="Text 19"/>
+          <p:cNvSpPr/>
+          <p:nvPr/>
+        </p:nvSpPr>
+        <p:spPr>
+          <a:xfrm>
+            <a:off x="594360" y="4555000"/>
+            <a:ext cx="8046720" cy="291320"/>
+          </a:xfrm>
+          <a:prstGeom prst="rect">
+            <a:avLst/>
+          </a:prstGeom>
+          <a:noFill/>
+          <a:ln/>
+        </p:spPr>
+        <p:txBody>
+          <a:bodyPr wrap="square" lIns="0" tIns="0" rIns="0" bIns="0" rtlCol="0" anchor="ctr"/>
+          <a:lstStyle/>
+          <a:p>
+            <a:pPr indent="0" marL="0">
+              <a:buNone/>
+            </a:pPr>
+            <a:r>
+              <a:rPr lang="en-US" sz="950" b="1" dirty="0">
+                <a:solidFill>
+                  <a:srgbClr val="C8761A"/>
+                </a:solidFill>
+                <a:latin typeface="Calibri" pitchFamily="34" charset="0"/>
+                <a:ea typeface="Calibri" pitchFamily="34" charset="-122"/>
+                <a:cs typeface="Calibri" pitchFamily="34" charset="-120"/>
+              </a:rPr>
+              <a:t xml:space="preserve">Engagement is an ML systems variable:  </a:t>
+            </a:r>
+            <a:pPr indent="0" marL="0">
+              <a:buNone/>
+            </a:pPr>
+            <a:r>
+              <a:rPr lang="en-US" sz="950" i="1" dirty="0">
+                <a:solidFill>
+                  <a:srgbClr val="E9E2D2"/>
+                </a:solidFill>
+                <a:latin typeface="Calibri" pitchFamily="34" charset="0"/>
+                <a:ea typeface="Calibri" pitchFamily="34" charset="-122"/>
+                <a:cs typeface="Calibri" pitchFamily="34" charset="-120"/>
+              </a:rPr>
+              <a:t>better DX creates better labels; better labels create better automation; better automation earns more trust.</a:t>
+            </a:r>
+            <a:endParaRPr lang="en-US" sz="1050" dirty="0"/>
+          </a:p>
+        </p:txBody>
+      </p:sp>
+      <p:sp>
+        <p:nvSpPr>
+          <p:cNvPr id="22" name="Text 20"/>
+          <p:cNvSpPr/>
+          <p:nvPr/>
+        </p:nvSpPr>
+        <p:spPr>
+          <a:xfrm>
+            <a:off x="457200" y="4846320"/>
+            <a:ext cx="5486400" cy="228600"/>
+          </a:xfrm>
+          <a:prstGeom prst="rect">
+            <a:avLst/>
+          </a:prstGeom>
+          <a:noFill/>
+          <a:ln/>
+        </p:spPr>
+        <p:txBody>
+          <a:bodyPr wrap="square" lIns="0" tIns="0" rIns="0" bIns="0" rtlCol="0" anchor="ctr"/>
+          <a:lstStyle/>
+          <a:p>
+            <a:pPr indent="0" marL="0">
+              <a:buNone/>
+            </a:pPr>
+            <a:r>
+              <a:rPr lang="en-US" sz="900" dirty="0">
+                <a:solidFill>
+                  <a:srgbClr val="4A4F57"/>
+                </a:solidFill>
+                <a:latin typeface="Calibri" pitchFamily="34" charset="0"/>
+                <a:ea typeface="Calibri" pitchFamily="34" charset="-122"/>
+                <a:cs typeface="Calibri" pitchFamily="34" charset="-120"/>
+              </a:rPr>
+              <a:t>Augrade · GNN strategy · M. Mabie</a:t>
+            </a:r>
+            <a:endParaRPr lang="en-US" sz="900" dirty="0"/>
+          </a:p>
+        </p:txBody>
+      </p:sp>
+      <p:sp>
+        <p:nvSpPr>
+          <p:cNvPr id="23" name="Text 21"/>
+          <p:cNvSpPr/>
+          <p:nvPr/>
+        </p:nvSpPr>
+        <p:spPr>
+          <a:xfrm>
+            <a:off x="8229600" y="4846320"/>
+            <a:ext cx="731520" cy="228600"/>
+          </a:xfrm>
+          <a:prstGeom prst="rect">
+            <a:avLst/>
+          </a:prstGeom>
+          <a:noFill/>
+          <a:ln/>
+        </p:spPr>
+        <p:txBody>
+          <a:bodyPr wrap="square" lIns="0" tIns="0" rIns="0" bIns="0" rtlCol="0" anchor="ctr"/>
+          <a:lstStyle/>
+          <a:p>
+            <a:pPr algn="r" indent="0" marL="0">
+              <a:buNone/>
+            </a:pPr>
+            <a:r>
+              <a:rPr lang="en-US" sz="900" dirty="0">
+                <a:solidFill>
+                  <a:srgbClr val="4A4F57"/>
+                </a:solidFill>
+                <a:latin typeface="Calibri" pitchFamily="34" charset="0"/>
+                <a:ea typeface="Calibri" pitchFamily="34" charset="-122"/>
+                <a:cs typeface="Calibri" pitchFamily="34" charset="-120"/>
+              </a:rPr>
+              <a:t>12 / 18</a:t>
+            </a:r>
+            <a:endParaRPr lang="en-US" sz="900" dirty="0"/>
+          </a:p>
+        </p:txBody>
+      </p:sp>
+    </p:spTree>
+  </p:cSld>
+  <p:clrMapOvr>
+    <a:masterClrMapping/>
+  </p:clrMapOvr>
+</p:sld>
+</file>
+
+<file path=ppt/slides/slide13.xml><?xml version="1.0" encoding="utf-8"?>
 <p:sld xmlns:a="http://schemas.openxmlformats.org/drawingml/2006/main" xmlns:r="http://schemas.openxmlformats.org/officeDocument/2006/relationships" xmlns:p="http://schemas.openxmlformats.org/presentationml/2006/main">
   <p:cSld name="Slide 12">
     <p:bg>
@@ -5355,6 +6622,10 @@
             <a:prstDash val="solid"/>
           </a:ln>
         </p:spPr>
+        <p:txBody>
+          <a:bodyPr/>
+          <a:p/>
+        </p:txBody>
       </p:sp>
       <p:sp>
         <p:nvSpPr>
@@ -5419,6 +6690,10 @@
             <a:prstDash val="solid"/>
           </a:ln>
         </p:spPr>
+        <p:txBody>
+          <a:bodyPr/>
+          <a:p/>
+        </p:txBody>
       </p:sp>
       <p:sp>
         <p:nvSpPr>
@@ -5439,6 +6714,10 @@
           </a:solidFill>
           <a:ln/>
         </p:spPr>
+        <p:txBody>
+          <a:bodyPr/>
+          <a:p/>
+        </p:txBody>
       </p:sp>
       <p:sp>
         <p:nvSpPr>
@@ -5625,6 +6904,10 @@
             <a:prstDash val="solid"/>
           </a:ln>
         </p:spPr>
+        <p:txBody>
+          <a:bodyPr/>
+          <a:p/>
+        </p:txBody>
       </p:sp>
       <p:sp>
         <p:nvSpPr>
@@ -5645,6 +6928,10 @@
           </a:solidFill>
           <a:ln/>
         </p:spPr>
+        <p:txBody>
+          <a:bodyPr/>
+          <a:p/>
+        </p:txBody>
       </p:sp>
       <p:sp>
         <p:nvSpPr>
@@ -5944,7 +7231,7 @@
 </p:sld>
 </file>
 
-<file path=ppt/slides/slide13.xml><?xml version="1.0" encoding="utf-8"?>
+<file path=ppt/slides/slide14.xml><?xml version="1.0" encoding="utf-8"?>
 <p:sld xmlns:a="http://schemas.openxmlformats.org/drawingml/2006/main" xmlns:r="http://schemas.openxmlformats.org/officeDocument/2006/relationships" xmlns:p="http://schemas.openxmlformats.org/presentationml/2006/main">
   <p:cSld name="Slide 13">
     <p:bg>
@@ -6029,6 +7316,10 @@
             <a:prstDash val="solid"/>
           </a:ln>
         </p:spPr>
+        <p:txBody>
+          <a:bodyPr/>
+          <a:p/>
+        </p:txBody>
       </p:sp>
       <p:sp>
         <p:nvSpPr>
@@ -6093,6 +7384,10 @@
             <a:prstDash val="solid"/>
           </a:ln>
         </p:spPr>
+        <p:txBody>
+          <a:bodyPr/>
+          <a:p/>
+        </p:txBody>
       </p:sp>
       <p:sp>
         <p:nvSpPr>
@@ -6113,6 +7408,10 @@
           </a:solidFill>
           <a:ln/>
         </p:spPr>
+        <p:txBody>
+          <a:bodyPr/>
+          <a:p/>
+        </p:txBody>
       </p:sp>
       <p:sp>
         <p:nvSpPr>
@@ -6358,6 +7657,10 @@
             <a:prstDash val="solid"/>
           </a:ln>
         </p:spPr>
+        <p:txBody>
+          <a:bodyPr/>
+          <a:p/>
+        </p:txBody>
       </p:sp>
       <p:sp>
         <p:nvSpPr>
@@ -6378,6 +7681,10 @@
           </a:solidFill>
           <a:ln/>
         </p:spPr>
+        <p:txBody>
+          <a:bodyPr/>
+          <a:p/>
+        </p:txBody>
       </p:sp>
       <p:sp>
         <p:nvSpPr>
@@ -6643,6 +7950,10 @@
             <a:prstDash val="solid"/>
           </a:ln>
         </p:spPr>
+        <p:txBody>
+          <a:bodyPr/>
+          <a:p/>
+        </p:txBody>
       </p:sp>
       <p:sp>
         <p:nvSpPr>
@@ -6663,6 +7974,10 @@
           </a:solidFill>
           <a:ln/>
         </p:spPr>
+        <p:txBody>
+          <a:bodyPr/>
+          <a:p/>
+        </p:txBody>
       </p:sp>
       <p:sp>
         <p:nvSpPr>
@@ -6923,6 +8238,10 @@
           </a:solidFill>
           <a:ln/>
         </p:spPr>
+        <p:txBody>
+          <a:bodyPr/>
+          <a:p/>
+        </p:txBody>
       </p:sp>
       <p:sp>
         <p:nvSpPr>
@@ -7063,7 +8382,7 @@
 </p:sld>
 </file>
 
-<file path=ppt/slides/slide14.xml><?xml version="1.0" encoding="utf-8"?>
+<file path=ppt/slides/slide15.xml><?xml version="1.0" encoding="utf-8"?>
 <p:sld xmlns:a="http://schemas.openxmlformats.org/drawingml/2006/main" xmlns:r="http://schemas.openxmlformats.org/officeDocument/2006/relationships" xmlns:p="http://schemas.openxmlformats.org/presentationml/2006/main">
   <p:cSld name="Slide 14">
     <p:bg>
@@ -7148,6 +8467,10 @@
             <a:prstDash val="solid"/>
           </a:ln>
         </p:spPr>
+        <p:txBody>
+          <a:bodyPr/>
+          <a:p/>
+        </p:txBody>
       </p:sp>
       <p:sp>
         <p:nvSpPr>
@@ -7246,6 +8569,10 @@
           </a:solidFill>
           <a:ln/>
         </p:spPr>
+        <p:txBody>
+          <a:bodyPr/>
+          <a:p/>
+        </p:txBody>
       </p:sp>
       <p:sp>
         <p:nvSpPr>
@@ -7383,6 +8710,10 @@
           </a:solidFill>
           <a:ln/>
         </p:spPr>
+        <p:txBody>
+          <a:bodyPr/>
+          <a:p/>
+        </p:txBody>
       </p:sp>
       <p:sp>
         <p:nvSpPr>
@@ -7520,6 +8851,10 @@
           </a:solidFill>
           <a:ln/>
         </p:spPr>
+        <p:txBody>
+          <a:bodyPr/>
+          <a:p/>
+        </p:txBody>
       </p:sp>
       <p:sp>
         <p:nvSpPr>
@@ -7657,6 +8992,10 @@
           </a:solidFill>
           <a:ln/>
         </p:spPr>
+        <p:txBody>
+          <a:bodyPr/>
+          <a:p/>
+        </p:txBody>
       </p:sp>
       <p:sp>
         <p:nvSpPr>
@@ -7794,6 +9133,10 @@
           </a:solidFill>
           <a:ln/>
         </p:spPr>
+        <p:txBody>
+          <a:bodyPr/>
+          <a:p/>
+        </p:txBody>
       </p:sp>
       <p:sp>
         <p:nvSpPr>
@@ -7931,6 +9274,10 @@
           </a:solidFill>
           <a:ln/>
         </p:spPr>
+        <p:txBody>
+          <a:bodyPr/>
+          <a:p/>
+        </p:txBody>
       </p:sp>
       <p:sp>
         <p:nvSpPr>
@@ -8071,6 +9418,10 @@
             <a:prstDash val="solid"/>
           </a:ln>
         </p:spPr>
+        <p:txBody>
+          <a:bodyPr/>
+          <a:p/>
+        </p:txBody>
       </p:sp>
       <p:sp>
         <p:nvSpPr>
@@ -8188,6 +9539,10 @@
             <a:prstDash val="solid"/>
           </a:ln>
         </p:spPr>
+        <p:txBody>
+          <a:bodyPr/>
+          <a:p/>
+        </p:txBody>
       </p:sp>
       <p:sp>
         <p:nvSpPr>
@@ -8208,6 +9563,10 @@
           </a:solidFill>
           <a:ln/>
         </p:spPr>
+        <p:txBody>
+          <a:bodyPr/>
+          <a:p/>
+        </p:txBody>
       </p:sp>
       <p:sp>
         <p:nvSpPr>
@@ -8350,6 +9709,10 @@
             <a:prstDash val="solid"/>
           </a:ln>
         </p:spPr>
+        <p:txBody>
+          <a:bodyPr/>
+          <a:p/>
+        </p:txBody>
       </p:sp>
       <p:sp>
         <p:nvSpPr>
@@ -8370,6 +9733,10 @@
           </a:solidFill>
           <a:ln/>
         </p:spPr>
+        <p:txBody>
+          <a:bodyPr/>
+          <a:p/>
+        </p:txBody>
       </p:sp>
       <p:sp>
         <p:nvSpPr>
@@ -8512,6 +9879,10 @@
             <a:prstDash val="solid"/>
           </a:ln>
         </p:spPr>
+        <p:txBody>
+          <a:bodyPr/>
+          <a:p/>
+        </p:txBody>
       </p:sp>
       <p:sp>
         <p:nvSpPr>
@@ -8532,6 +9903,10 @@
           </a:solidFill>
           <a:ln/>
         </p:spPr>
+        <p:txBody>
+          <a:bodyPr/>
+          <a:p/>
+        </p:txBody>
       </p:sp>
       <p:sp>
         <p:nvSpPr>
@@ -8674,6 +10049,10 @@
             <a:prstDash val="solid"/>
           </a:ln>
         </p:spPr>
+        <p:txBody>
+          <a:bodyPr/>
+          <a:p/>
+        </p:txBody>
       </p:sp>
       <p:sp>
         <p:nvSpPr>
@@ -8694,6 +10073,10 @@
           </a:solidFill>
           <a:ln/>
         </p:spPr>
+        <p:txBody>
+          <a:bodyPr/>
+          <a:p/>
+        </p:txBody>
       </p:sp>
       <p:sp>
         <p:nvSpPr>
@@ -8831,6 +10214,10 @@
           </a:solidFill>
           <a:ln/>
         </p:spPr>
+        <p:txBody>
+          <a:bodyPr/>
+          <a:p/>
+        </p:txBody>
       </p:sp>
       <p:sp>
         <p:nvSpPr>
@@ -8971,7 +10358,7 @@
 </p:sld>
 </file>
 
-<file path=ppt/slides/slide15.xml><?xml version="1.0" encoding="utf-8"?>
+<file path=ppt/slides/slide16.xml><?xml version="1.0" encoding="utf-8"?>
 <p:sld xmlns:a="http://schemas.openxmlformats.org/drawingml/2006/main" xmlns:r="http://schemas.openxmlformats.org/officeDocument/2006/relationships" xmlns:p="http://schemas.openxmlformats.org/presentationml/2006/main">
   <p:cSld name="Slide 15">
     <p:bg>
@@ -9056,6 +10443,10 @@
             <a:prstDash val="solid"/>
           </a:ln>
         </p:spPr>
+        <p:txBody>
+          <a:bodyPr/>
+          <a:p/>
+        </p:txBody>
       </p:sp>
       <p:sp>
         <p:nvSpPr>
@@ -9120,6 +10511,10 @@
             <a:prstDash val="solid"/>
           </a:ln>
         </p:spPr>
+        <p:txBody>
+          <a:bodyPr/>
+          <a:p/>
+        </p:txBody>
       </p:sp>
       <p:sp>
         <p:nvSpPr>
@@ -9140,6 +10535,10 @@
           </a:solidFill>
           <a:ln/>
         </p:spPr>
+        <p:txBody>
+          <a:bodyPr/>
+          <a:p/>
+        </p:txBody>
       </p:sp>
       <p:sp>
         <p:nvSpPr>
@@ -9345,6 +10744,10 @@
             <a:prstDash val="solid"/>
           </a:ln>
         </p:spPr>
+        <p:txBody>
+          <a:bodyPr/>
+          <a:p/>
+        </p:txBody>
       </p:sp>
       <p:sp>
         <p:nvSpPr>
@@ -9365,6 +10768,10 @@
           </a:solidFill>
           <a:ln/>
         </p:spPr>
+        <p:txBody>
+          <a:bodyPr/>
+          <a:p/>
+        </p:txBody>
       </p:sp>
       <p:sp>
         <p:nvSpPr>
@@ -9570,6 +10977,10 @@
             <a:prstDash val="solid"/>
           </a:ln>
         </p:spPr>
+        <p:txBody>
+          <a:bodyPr/>
+          <a:p/>
+        </p:txBody>
       </p:sp>
       <p:sp>
         <p:nvSpPr>
@@ -9590,6 +11001,10 @@
           </a:solidFill>
           <a:ln/>
         </p:spPr>
+        <p:txBody>
+          <a:bodyPr/>
+          <a:p/>
+        </p:txBody>
       </p:sp>
       <p:sp>
         <p:nvSpPr>
@@ -9790,6 +11205,10 @@
           </a:solidFill>
           <a:ln/>
         </p:spPr>
+        <p:txBody>
+          <a:bodyPr/>
+          <a:p/>
+        </p:txBody>
       </p:sp>
       <p:sp>
         <p:nvSpPr>
@@ -9930,7 +11349,7 @@
 </p:sld>
 </file>
 
-<file path=ppt/slides/slide16.xml><?xml version="1.0" encoding="utf-8"?>
+<file path=ppt/slides/slide17.xml><?xml version="1.0" encoding="utf-8"?>
 <p:sld xmlns:a="http://schemas.openxmlformats.org/drawingml/2006/main" xmlns:r="http://schemas.openxmlformats.org/officeDocument/2006/relationships" xmlns:p="http://schemas.openxmlformats.org/presentationml/2006/main">
   <p:cSld name="Slide 16">
     <p:bg>
@@ -10015,6 +11434,10 @@
             <a:prstDash val="solid"/>
           </a:ln>
         </p:spPr>
+        <p:txBody>
+          <a:bodyPr/>
+          <a:p/>
+        </p:txBody>
       </p:sp>
       <p:sp>
         <p:nvSpPr>
@@ -10074,6 +11497,10 @@
           </a:solidFill>
           <a:ln/>
         </p:spPr>
+        <p:txBody>
+          <a:bodyPr/>
+          <a:p/>
+        </p:txBody>
       </p:sp>
       <p:sp>
         <p:nvSpPr>
@@ -10172,6 +11599,10 @@
           </a:solidFill>
           <a:ln/>
         </p:spPr>
+        <p:txBody>
+          <a:bodyPr/>
+          <a:p/>
+        </p:txBody>
       </p:sp>
       <p:sp>
         <p:nvSpPr>
@@ -10270,6 +11701,10 @@
           </a:solidFill>
           <a:ln/>
         </p:spPr>
+        <p:txBody>
+          <a:bodyPr/>
+          <a:p/>
+        </p:txBody>
       </p:sp>
       <p:sp>
         <p:nvSpPr>
@@ -10368,6 +11803,10 @@
           </a:solidFill>
           <a:ln/>
         </p:spPr>
+        <p:txBody>
+          <a:bodyPr/>
+          <a:p/>
+        </p:txBody>
       </p:sp>
       <p:sp>
         <p:nvSpPr>
@@ -10466,6 +11905,10 @@
           </a:solidFill>
           <a:ln/>
         </p:spPr>
+        <p:txBody>
+          <a:bodyPr/>
+          <a:p/>
+        </p:txBody>
       </p:sp>
       <p:sp>
         <p:nvSpPr>
@@ -10564,6 +12007,10 @@
           </a:solidFill>
           <a:ln/>
         </p:spPr>
+        <p:txBody>
+          <a:bodyPr/>
+          <a:p/>
+        </p:txBody>
       </p:sp>
       <p:sp>
         <p:nvSpPr>
@@ -10729,7 +12176,7 @@
 </p:sld>
 </file>
 
-<file path=ppt/slides/slide17.xml><?xml version="1.0" encoding="utf-8"?>
+<file path=ppt/slides/slide18.xml><?xml version="1.0" encoding="utf-8"?>
 <p:sld xmlns:a="http://schemas.openxmlformats.org/drawingml/2006/main" xmlns:r="http://schemas.openxmlformats.org/officeDocument/2006/relationships" xmlns:p="http://schemas.openxmlformats.org/presentationml/2006/main">
   <p:cSld name="Slide 17">
     <p:bg>
@@ -10772,6 +12219,10 @@
           </a:solidFill>
           <a:ln/>
         </p:spPr>
+        <p:txBody>
+          <a:bodyPr/>
+          <a:p/>
+        </p:txBody>
       </p:sp>
       <p:sp>
         <p:nvSpPr>
@@ -10792,6 +12243,10 @@
           </a:solidFill>
           <a:ln/>
         </p:spPr>
+        <p:txBody>
+          <a:bodyPr/>
+          <a:p/>
+        </p:txBody>
       </p:sp>
       <p:sp>
         <p:nvSpPr>
@@ -10812,6 +12267,10 @@
           </a:solidFill>
           <a:ln/>
         </p:spPr>
+        <p:txBody>
+          <a:bodyPr/>
+          <a:p/>
+        </p:txBody>
       </p:sp>
       <p:sp>
         <p:nvSpPr>
@@ -10832,6 +12291,10 @@
           </a:solidFill>
           <a:ln/>
         </p:spPr>
+        <p:txBody>
+          <a:bodyPr/>
+          <a:p/>
+        </p:txBody>
       </p:sp>
       <p:sp>
         <p:nvSpPr>
@@ -10852,6 +12315,10 @@
           </a:solidFill>
           <a:ln/>
         </p:spPr>
+        <p:txBody>
+          <a:bodyPr/>
+          <a:p/>
+        </p:txBody>
       </p:sp>
       <p:sp>
         <p:nvSpPr>
@@ -10872,6 +12339,10 @@
           </a:solidFill>
           <a:ln/>
         </p:spPr>
+        <p:txBody>
+          <a:bodyPr/>
+          <a:p/>
+        </p:txBody>
       </p:sp>
       <p:sp>
         <p:nvSpPr>
@@ -10892,6 +12363,10 @@
           </a:solidFill>
           <a:ln/>
         </p:spPr>
+        <p:txBody>
+          <a:bodyPr/>
+          <a:p/>
+        </p:txBody>
       </p:sp>
       <p:sp>
         <p:nvSpPr>
@@ -10912,6 +12387,10 @@
           </a:solidFill>
           <a:ln/>
         </p:spPr>
+        <p:txBody>
+          <a:bodyPr/>
+          <a:p/>
+        </p:txBody>
       </p:sp>
       <p:sp>
         <p:nvSpPr>
@@ -10974,6 +12453,10 @@
             <a:prstDash val="solid"/>
           </a:ln>
         </p:spPr>
+        <p:txBody>
+          <a:bodyPr/>
+          <a:p/>
+        </p:txBody>
       </p:sp>
       <p:sp>
         <p:nvSpPr>
@@ -11147,6 +12630,10 @@
             <a:prstDash val="solid"/>
           </a:ln>
         </p:spPr>
+        <p:txBody>
+          <a:bodyPr/>
+          <a:p/>
+        </p:txBody>
       </p:sp>
       <p:sp>
         <p:nvSpPr>
@@ -11329,1106 +12816,7 @@
                 <a:ea typeface="Consolas" pitchFamily="34" charset="-122"/>
                 <a:cs typeface="Consolas" pitchFamily="34" charset="-120"/>
               </a:rPr>
-              <a:t>DXF_Primitive_to_Polygon · gnn-plan-setup</a:t>
-            </a:r>
-            <a:endParaRPr lang="en-US" sz="900" dirty="0"/>
-          </a:p>
-        </p:txBody>
-      </p:sp>
-    </p:spTree>
-  </p:cSld>
-  <p:clrMapOvr>
-    <a:masterClrMapping/>
-  </p:clrMapOvr>
-</p:sld>
-</file>
-
-<file path=ppt/slides/slide18.xml><?xml version="1.0" encoding="utf-8"?>
-<p:sld xmlns:a="http://schemas.openxmlformats.org/drawingml/2006/main" xmlns:r="http://schemas.openxmlformats.org/officeDocument/2006/relationships" xmlns:p="http://schemas.openxmlformats.org/presentationml/2006/main">
-  <p:cSld name="Slide 13">
-    <p:bg>
-      <p:bgPr>
-        <a:solidFill>
-          <a:srgbClr val="F7F5F2"/>
-        </a:solidFill>
-      </p:bgPr>
-    </p:bg>
-    <p:spTree>
-      <p:nvGrpSpPr>
-        <p:cNvPr id="1" name=""/>
-        <p:cNvGrpSpPr/>
-        <p:nvPr/>
-      </p:nvGrpSpPr>
-      <p:grpSpPr>
-        <a:xfrm>
-          <a:off x="0" y="0"/>
-          <a:ext cx="0" cy="0"/>
-          <a:chOff x="0" y="0"/>
-          <a:chExt cx="0" cy="0"/>
-        </a:xfrm>
-      </p:grpSpPr>
-      <p:sp>
-        <p:nvSpPr>
-          <p:cNvPr id="2" name="Text 0"/>
-          <p:cNvSpPr/>
-          <p:nvPr/>
-        </p:nvSpPr>
-        <p:spPr>
-          <a:xfrm>
-            <a:off x="457200" y="365760"/>
-            <a:ext cx="8229600" cy="457200"/>
-          </a:xfrm>
-          <a:prstGeom prst="rect">
-            <a:avLst/>
-          </a:prstGeom>
-          <a:noFill/>
-          <a:ln/>
-        </p:spPr>
-        <p:txBody>
-          <a:bodyPr wrap="square" lIns="0" tIns="0" rIns="0" bIns="0" rtlCol="0" anchor="ctr"/>
-          <a:lstStyle/>
-          <a:p>
-            <a:pPr indent="0" marL="0">
-              <a:buNone/>
-            </a:pPr>
-            <a:r>
-              <a:rPr lang="en-US" sz="1400" spc="1000" kern="0" dirty="0">
-                <a:solidFill>
-                  <a:srgbClr val="4A4F57"/>
-                </a:solidFill>
-                <a:latin typeface="Georgia" pitchFamily="34" charset="0"/>
-                <a:ea typeface="Georgia" pitchFamily="34" charset="-122"/>
-                <a:cs typeface="Georgia" pitchFamily="34" charset="-120"/>
-              </a:rPr>
-              <a:t>Quality loops: make review worth doing</a:t>
-            </a:r>
-            <a:endParaRPr lang="en-US" sz="1400" dirty="0"/>
-          </a:p>
-        </p:txBody>
-      </p:sp>
-      <p:sp>
-        <p:nvSpPr>
-          <p:cNvPr id="3" name="Shape 1"/>
-          <p:cNvSpPr/>
-          <p:nvPr/>
-        </p:nvSpPr>
-        <p:spPr>
-          <a:xfrm>
-            <a:off x="457200" y="777240"/>
-            <a:ext cx="914400" cy="0"/>
-          </a:xfrm>
-          <a:prstGeom prst="line">
-            <a:avLst/>
-          </a:prstGeom>
-          <a:noFill/>
-          <a:ln w="19050">
-            <a:solidFill>
-              <a:srgbClr val="C8761A"/>
-            </a:solidFill>
-            <a:prstDash val="solid"/>
-          </a:ln>
-        </p:spPr>
-      </p:sp>
-      <p:sp>
-        <p:nvSpPr>
-          <p:cNvPr id="4" name="Text 2"/>
-          <p:cNvSpPr/>
-          <p:nvPr/>
-        </p:nvSpPr>
-        <p:spPr>
-          <a:xfrm>
-            <a:off x="457200" y="914400"/>
-            <a:ext cx="8229600" cy="457200"/>
-          </a:xfrm>
-          <a:prstGeom prst="rect">
-            <a:avLst/>
-          </a:prstGeom>
-          <a:noFill/>
-          <a:ln/>
-        </p:spPr>
-        <p:txBody>
-          <a:bodyPr wrap="square" lIns="0" tIns="0" rIns="0" bIns="0" rtlCol="0" anchor="ctr"/>
-          <a:lstStyle/>
-          <a:p>
-            <a:pPr indent="0" marL="0">
-              <a:buNone/>
-            </a:pPr>
-            <a:r>
-              <a:rPr lang="en-US" sz="1700" b="1" dirty="0">
-                <a:solidFill>
-                  <a:srgbClr val="1B1D22"/>
-                </a:solidFill>
-                <a:latin typeface="Georgia" pitchFamily="34" charset="0"/>
-                <a:ea typeface="Georgia" pitchFamily="34" charset="-122"/>
-                <a:cs typeface="Georgia" pitchFamily="34" charset="-120"/>
-              </a:rPr>
-              <a:t>The human loop is not a tax. It is the product surface where expertise becomes data.</a:t>
-            </a:r>
-            <a:endParaRPr lang="en-US" sz="1700" dirty="0"/>
-          </a:p>
-        </p:txBody>
-      </p:sp>
-      <p:sp>
-        <p:nvSpPr>
-          <p:cNvPr id="5" name="Shape 3"/>
-          <p:cNvSpPr/>
-          <p:nvPr/>
-        </p:nvSpPr>
-        <p:spPr>
-          <a:xfrm>
-            <a:off x="502920" y="1627632"/>
-            <a:ext cx="2697480" cy="2926080"/>
-          </a:xfrm>
-          <a:prstGeom prst="rect">
-            <a:avLst/>
-          </a:prstGeom>
-          <a:solidFill>
-            <a:srgbClr val="FFFFFF"/>
-          </a:solidFill>
-          <a:ln w="6350">
-            <a:solidFill>
-              <a:srgbClr val="C9C2B7"/>
-            </a:solidFill>
-            <a:prstDash val="solid"/>
-          </a:ln>
-        </p:spPr>
-      </p:sp>
-      <p:sp>
-        <p:nvSpPr>
-          <p:cNvPr id="6" name="Shape 4"/>
-          <p:cNvSpPr/>
-          <p:nvPr/>
-        </p:nvSpPr>
-        <p:spPr>
-          <a:xfrm>
-            <a:off x="502920" y="1627632"/>
-            <a:ext cx="73152" cy="2926080"/>
-          </a:xfrm>
-          <a:prstGeom prst="rect">
-            <a:avLst/>
-          </a:prstGeom>
-          <a:solidFill>
-            <a:srgbClr val="4A4F57"/>
-          </a:solidFill>
-          <a:ln/>
-        </p:spPr>
-      </p:sp>
-      <p:sp>
-        <p:nvSpPr>
-          <p:cNvPr id="7" name="Text 5"/>
-          <p:cNvSpPr/>
-          <p:nvPr/>
-        </p:nvSpPr>
-        <p:spPr>
-          <a:xfrm>
-            <a:off x="777240" y="1792224"/>
-            <a:ext cx="2331720" cy="292608"/>
-          </a:xfrm>
-          <a:prstGeom prst="rect">
-            <a:avLst/>
-          </a:prstGeom>
-          <a:noFill/>
-          <a:ln/>
-        </p:spPr>
-        <p:txBody>
-          <a:bodyPr wrap="square" lIns="0" tIns="0" rIns="0" bIns="0" rtlCol="0" anchor="ctr"/>
-          <a:lstStyle/>
-          <a:p>
-            <a:pPr indent="0" marL="0">
-              <a:buNone/>
-            </a:pPr>
-            <a:r>
-              <a:rPr lang="en-US" sz="1400" b="1" dirty="0">
-                <a:solidFill>
-                  <a:srgbClr val="1B1D22"/>
-                </a:solidFill>
-                <a:latin typeface="Georgia" pitchFamily="34" charset="0"/>
-                <a:ea typeface="Georgia" pitchFamily="34" charset="-122"/>
-                <a:cs typeface="Georgia" pitchFamily="34" charset="-120"/>
-              </a:rPr>
-              <a:t>Operator sees</a:t>
-            </a:r>
-            <a:endParaRPr lang="en-US" sz="1400" dirty="0"/>
-          </a:p>
-        </p:txBody>
-      </p:sp>
-      <p:sp>
-        <p:nvSpPr>
-          <p:cNvPr id="8" name="Text 6"/>
-          <p:cNvSpPr/>
-          <p:nvPr/>
-        </p:nvSpPr>
-        <p:spPr>
-          <a:xfrm>
-            <a:off x="777240" y="2084832"/>
-            <a:ext cx="2331720" cy="219456"/>
-          </a:xfrm>
-          <a:prstGeom prst="rect">
-            <a:avLst/>
-          </a:prstGeom>
-          <a:noFill/>
-          <a:ln/>
-        </p:spPr>
-        <p:txBody>
-          <a:bodyPr wrap="square" lIns="0" tIns="0" rIns="0" bIns="0" rtlCol="0" anchor="ctr"/>
-          <a:lstStyle/>
-          <a:p>
-            <a:pPr indent="0" marL="0">
-              <a:buNone/>
-            </a:pPr>
-            <a:r>
-              <a:rPr lang="en-US" sz="950" i="1" dirty="0">
-                <a:solidFill>
-                  <a:srgbClr val="4A4F57"/>
-                </a:solidFill>
-                <a:latin typeface="Calibri" pitchFamily="34" charset="0"/>
-                <a:ea typeface="Calibri" pitchFamily="34" charset="-122"/>
-                <a:cs typeface="Calibri" pitchFamily="34" charset="-120"/>
-              </a:rPr>
-              <a:t>in the review surface</a:t>
-            </a:r>
-            <a:endParaRPr lang="en-US" sz="950" dirty="0"/>
-          </a:p>
-        </p:txBody>
-      </p:sp>
-      <p:sp>
-        <p:nvSpPr>
-          <p:cNvPr id="9" name="Text 7"/>
-          <p:cNvSpPr/>
-          <p:nvPr/>
-        </p:nvSpPr>
-        <p:spPr>
-          <a:xfrm>
-            <a:off x="777240" y="2359152"/>
-            <a:ext cx="2286000" cy="2103120"/>
-          </a:xfrm>
-          <a:prstGeom prst="rect">
-            <a:avLst/>
-          </a:prstGeom>
-          <a:noFill/>
-          <a:ln/>
-        </p:spPr>
-        <p:txBody>
-          <a:bodyPr wrap="square" lIns="0" tIns="0" rIns="0" bIns="0" rtlCol="0" anchor="t"/>
-          <a:lstStyle/>
-          <a:p>
-            <a:pPr indent="0" marL="0">
-              <a:spcAft>
-                <a:spcPts val="400"/>
-              </a:spcAft>
-              <a:buNone/>
-            </a:pPr>
-            <a:r>
-              <a:rPr lang="en-US" sz="1000" dirty="0">
-                <a:solidFill>
-                  <a:srgbClr val="4A4F57"/>
-                </a:solidFill>
-                <a:latin typeface="Calibri" pitchFamily="34" charset="0"/>
-                <a:ea typeface="Calibri" pitchFamily="34" charset="-122"/>
-                <a:cs typeface="Calibri" pitchFamily="34" charset="-120"/>
-              </a:rPr>
-              <a:t>before / after overlay</a:t>
-            </a:r>
-            <a:endParaRPr lang="en-US" sz="1000" dirty="0"/>
-          </a:p>
-          <a:p>
-            <a:pPr indent="0" marL="0">
-              <a:spcAft>
-                <a:spcPts val="400"/>
-              </a:spcAft>
-              <a:buNone/>
-            </a:pPr>
-            <a:r>
-              <a:rPr lang="en-US" sz="1000" dirty="0">
-                <a:solidFill>
-                  <a:srgbClr val="4A4F57"/>
-                </a:solidFill>
-                <a:latin typeface="Calibri" pitchFamily="34" charset="0"/>
-                <a:ea typeface="Calibri" pitchFamily="34" charset="-122"/>
-                <a:cs typeface="Calibri" pitchFamily="34" charset="-120"/>
-              </a:rPr>
-              <a:t>model hypothesis</a:t>
-            </a:r>
-            <a:endParaRPr lang="en-US" sz="1000" dirty="0"/>
-          </a:p>
-          <a:p>
-            <a:pPr indent="0" marL="0">
-              <a:spcAft>
-                <a:spcPts val="400"/>
-              </a:spcAft>
-              <a:buNone/>
-            </a:pPr>
-            <a:r>
-              <a:rPr lang="en-US" sz="1000" dirty="0">
-                <a:solidFill>
-                  <a:srgbClr val="4A4F57"/>
-                </a:solidFill>
-                <a:latin typeface="Calibri" pitchFamily="34" charset="0"/>
-                <a:ea typeface="Calibri" pitchFamily="34" charset="-122"/>
-                <a:cs typeface="Calibri" pitchFamily="34" charset="-120"/>
-              </a:rPr>
-              <a:t>validator residual</a:t>
-            </a:r>
-            <a:endParaRPr lang="en-US" sz="1000" dirty="0"/>
-          </a:p>
-          <a:p>
-            <a:pPr indent="0" marL="0">
-              <a:spcAft>
-                <a:spcPts val="400"/>
-              </a:spcAft>
-              <a:buNone/>
-            </a:pPr>
-            <a:r>
-              <a:rPr lang="en-US" sz="1000" dirty="0">
-                <a:solidFill>
-                  <a:srgbClr val="4A4F57"/>
-                </a:solidFill>
-                <a:latin typeface="Calibri" pitchFamily="34" charset="0"/>
-                <a:ea typeface="Calibri" pitchFamily="34" charset="-122"/>
-                <a:cs typeface="Calibri" pitchFamily="34" charset="-120"/>
-              </a:rPr>
-              <a:t>similar past cases</a:t>
-            </a:r>
-            <a:endParaRPr lang="en-US" sz="1000" dirty="0"/>
-          </a:p>
-          <a:p>
-            <a:pPr indent="0" marL="0">
-              <a:spcAft>
-                <a:spcPts val="400"/>
-              </a:spcAft>
-              <a:buNone/>
-            </a:pPr>
-            <a:r>
-              <a:rPr lang="en-US" sz="1000" dirty="0">
-                <a:solidFill>
-                  <a:srgbClr val="4A4F57"/>
-                </a:solidFill>
-                <a:latin typeface="Calibri" pitchFamily="34" charset="0"/>
-                <a:ea typeface="Calibri" pitchFamily="34" charset="-122"/>
-                <a:cs typeface="Calibri" pitchFamily="34" charset="-120"/>
-              </a:rPr>
-              <a:t>one-click approve / reject / repair</a:t>
-            </a:r>
-            <a:endParaRPr lang="en-US" sz="1000" dirty="0"/>
-          </a:p>
-          <a:p>
-            <a:pPr indent="0" marL="0">
-              <a:spcAft>
-                <a:spcPts val="400"/>
-              </a:spcAft>
-              <a:buNone/>
-            </a:pPr>
-            <a:r>
-              <a:rPr lang="en-US" sz="1000" dirty="0">
-                <a:solidFill>
-                  <a:srgbClr val="4A4F57"/>
-                </a:solidFill>
-                <a:latin typeface="Calibri" pitchFamily="34" charset="0"/>
-                <a:ea typeface="Calibri" pitchFamily="34" charset="-122"/>
-                <a:cs typeface="Calibri" pitchFamily="34" charset="-120"/>
-              </a:rPr>
-              <a:t>why-it-matters explanation</a:t>
-            </a:r>
-            <a:endParaRPr lang="en-US" sz="1000" dirty="0"/>
-          </a:p>
-        </p:txBody>
-      </p:sp>
-      <p:sp>
-        <p:nvSpPr>
-          <p:cNvPr id="10" name="Shape 8"/>
-          <p:cNvSpPr/>
-          <p:nvPr/>
-        </p:nvSpPr>
-        <p:spPr>
-          <a:xfrm>
-            <a:off x="3291840" y="1627632"/>
-            <a:ext cx="2697480" cy="2926080"/>
-          </a:xfrm>
-          <a:prstGeom prst="rect">
-            <a:avLst/>
-          </a:prstGeom>
-          <a:solidFill>
-            <a:srgbClr val="FFFFFF"/>
-          </a:solidFill>
-          <a:ln w="6350">
-            <a:solidFill>
-              <a:srgbClr val="C9C2B7"/>
-            </a:solidFill>
-            <a:prstDash val="solid"/>
-          </a:ln>
-        </p:spPr>
-      </p:sp>
-      <p:sp>
-        <p:nvSpPr>
-          <p:cNvPr id="11" name="Shape 9"/>
-          <p:cNvSpPr/>
-          <p:nvPr/>
-        </p:nvSpPr>
-        <p:spPr>
-          <a:xfrm>
-            <a:off x="3291840" y="1627632"/>
-            <a:ext cx="73152" cy="2926080"/>
-          </a:xfrm>
-          <a:prstGeom prst="rect">
-            <a:avLst/>
-          </a:prstGeom>
-          <a:solidFill>
-            <a:srgbClr val="C8761A"/>
-          </a:solidFill>
-          <a:ln/>
-        </p:spPr>
-      </p:sp>
-      <p:sp>
-        <p:nvSpPr>
-          <p:cNvPr id="12" name="Text 10"/>
-          <p:cNvSpPr/>
-          <p:nvPr/>
-        </p:nvSpPr>
-        <p:spPr>
-          <a:xfrm>
-            <a:off x="3566160" y="1792224"/>
-            <a:ext cx="2331720" cy="292608"/>
-          </a:xfrm>
-          <a:prstGeom prst="rect">
-            <a:avLst/>
-          </a:prstGeom>
-          <a:noFill/>
-          <a:ln/>
-        </p:spPr>
-        <p:txBody>
-          <a:bodyPr wrap="square" lIns="0" tIns="0" rIns="0" bIns="0" rtlCol="0" anchor="ctr"/>
-          <a:lstStyle/>
-          <a:p>
-            <a:pPr indent="0" marL="0">
-              <a:buNone/>
-            </a:pPr>
-            <a:r>
-              <a:rPr lang="en-US" sz="1400" b="1" dirty="0">
-                <a:solidFill>
-                  <a:srgbClr val="1B1D22"/>
-                </a:solidFill>
-                <a:latin typeface="Georgia" pitchFamily="34" charset="0"/>
-                <a:ea typeface="Georgia" pitchFamily="34" charset="-122"/>
-                <a:cs typeface="Georgia" pitchFamily="34" charset="-120"/>
-              </a:rPr>
-              <a:t>System captures</a:t>
-            </a:r>
-            <a:endParaRPr lang="en-US" sz="1400" dirty="0"/>
-          </a:p>
-        </p:txBody>
-      </p:sp>
-      <p:sp>
-        <p:nvSpPr>
-          <p:cNvPr id="13" name="Text 11"/>
-          <p:cNvSpPr/>
-          <p:nvPr/>
-        </p:nvSpPr>
-        <p:spPr>
-          <a:xfrm>
-            <a:off x="3566160" y="2084832"/>
-            <a:ext cx="2331720" cy="219456"/>
-          </a:xfrm>
-          <a:prstGeom prst="rect">
-            <a:avLst/>
-          </a:prstGeom>
-          <a:noFill/>
-          <a:ln/>
-        </p:spPr>
-        <p:txBody>
-          <a:bodyPr wrap="square" lIns="0" tIns="0" rIns="0" bIns="0" rtlCol="0" anchor="ctr"/>
-          <a:lstStyle/>
-          <a:p>
-            <a:pPr indent="0" marL="0">
-              <a:buNone/>
-            </a:pPr>
-            <a:r>
-              <a:rPr lang="en-US" sz="950" i="1" dirty="0">
-                <a:solidFill>
-                  <a:srgbClr val="4A4F57"/>
-                </a:solidFill>
-                <a:latin typeface="Calibri" pitchFamily="34" charset="0"/>
-                <a:ea typeface="Calibri" pitchFamily="34" charset="-122"/>
-                <a:cs typeface="Calibri" pitchFamily="34" charset="-120"/>
-              </a:rPr>
-              <a:t>into persistent memory</a:t>
-            </a:r>
-            <a:endParaRPr lang="en-US" sz="950" dirty="0"/>
-          </a:p>
-        </p:txBody>
-      </p:sp>
-      <p:sp>
-        <p:nvSpPr>
-          <p:cNvPr id="14" name="Text 12"/>
-          <p:cNvSpPr/>
-          <p:nvPr/>
-        </p:nvSpPr>
-        <p:spPr>
-          <a:xfrm>
-            <a:off x="3566160" y="2359152"/>
-            <a:ext cx="2286000" cy="2103120"/>
-          </a:xfrm>
-          <a:prstGeom prst="rect">
-            <a:avLst/>
-          </a:prstGeom>
-          <a:noFill/>
-          <a:ln/>
-        </p:spPr>
-        <p:txBody>
-          <a:bodyPr wrap="square" lIns="0" tIns="0" rIns="0" bIns="0" rtlCol="0" anchor="t"/>
-          <a:lstStyle/>
-          <a:p>
-            <a:pPr indent="0" marL="0">
-              <a:spcAft>
-                <a:spcPts val="400"/>
-              </a:spcAft>
-              <a:buNone/>
-            </a:pPr>
-            <a:r>
-              <a:rPr lang="en-US" sz="1000" dirty="0">
-                <a:solidFill>
-                  <a:srgbClr val="4A4F57"/>
-                </a:solidFill>
-                <a:latin typeface="Calibri" pitchFamily="34" charset="0"/>
-                <a:ea typeface="Calibri" pitchFamily="34" charset="-122"/>
-                <a:cs typeface="Calibri" pitchFamily="34" charset="-120"/>
-              </a:rPr>
-              <a:t>label / preference</a:t>
-            </a:r>
-            <a:endParaRPr lang="en-US" sz="1000" dirty="0"/>
-          </a:p>
-          <a:p>
-            <a:pPr indent="0" marL="0">
-              <a:spcAft>
-                <a:spcPts val="400"/>
-              </a:spcAft>
-              <a:buNone/>
-            </a:pPr>
-            <a:r>
-              <a:rPr lang="en-US" sz="1000" dirty="0">
-                <a:solidFill>
-                  <a:srgbClr val="4A4F57"/>
-                </a:solidFill>
-                <a:latin typeface="Calibri" pitchFamily="34" charset="0"/>
-                <a:ea typeface="Calibri" pitchFamily="34" charset="-122"/>
-                <a:cs typeface="Calibri" pitchFamily="34" charset="-120"/>
-              </a:rPr>
-              <a:t>correction trace</a:t>
-            </a:r>
-            <a:endParaRPr lang="en-US" sz="1000" dirty="0"/>
-          </a:p>
-          <a:p>
-            <a:pPr indent="0" marL="0">
-              <a:spcAft>
-                <a:spcPts val="400"/>
-              </a:spcAft>
-              <a:buNone/>
-            </a:pPr>
-            <a:r>
-              <a:rPr lang="en-US" sz="1000" dirty="0">
-                <a:solidFill>
-                  <a:srgbClr val="4A4F57"/>
-                </a:solidFill>
-                <a:latin typeface="Calibri" pitchFamily="34" charset="0"/>
-                <a:ea typeface="Calibri" pitchFamily="34" charset="-122"/>
-                <a:cs typeface="Calibri" pitchFamily="34" charset="-120"/>
-              </a:rPr>
-              <a:t>edit delta</a:t>
-            </a:r>
-            <a:endParaRPr lang="en-US" sz="1000" dirty="0"/>
-          </a:p>
-          <a:p>
-            <a:pPr indent="0" marL="0">
-              <a:spcAft>
-                <a:spcPts val="400"/>
-              </a:spcAft>
-              <a:buNone/>
-            </a:pPr>
-            <a:r>
-              <a:rPr lang="en-US" sz="1000" dirty="0">
-                <a:solidFill>
-                  <a:srgbClr val="4A4F57"/>
-                </a:solidFill>
-                <a:latin typeface="Calibri" pitchFamily="34" charset="0"/>
-                <a:ea typeface="Calibri" pitchFamily="34" charset="-122"/>
-                <a:cs typeface="Calibri" pitchFamily="34" charset="-120"/>
-              </a:rPr>
-              <a:t>validator before / after</a:t>
-            </a:r>
-            <a:endParaRPr lang="en-US" sz="1000" dirty="0"/>
-          </a:p>
-          <a:p>
-            <a:pPr indent="0" marL="0">
-              <a:spcAft>
-                <a:spcPts val="400"/>
-              </a:spcAft>
-              <a:buNone/>
-            </a:pPr>
-            <a:r>
-              <a:rPr lang="en-US" sz="1000" dirty="0">
-                <a:solidFill>
-                  <a:srgbClr val="4A4F57"/>
-                </a:solidFill>
-                <a:latin typeface="Calibri" pitchFamily="34" charset="0"/>
-                <a:ea typeface="Calibri" pitchFamily="34" charset="-122"/>
-                <a:cs typeface="Calibri" pitchFamily="34" charset="-120"/>
-              </a:rPr>
-              <a:t>time-to-fix</a:t>
-            </a:r>
-            <a:endParaRPr lang="en-US" sz="1000" dirty="0"/>
-          </a:p>
-          <a:p>
-            <a:pPr indent="0" marL="0">
-              <a:spcAft>
-                <a:spcPts val="400"/>
-              </a:spcAft>
-              <a:buNone/>
-            </a:pPr>
-            <a:r>
-              <a:rPr lang="en-US" sz="1000" dirty="0">
-                <a:solidFill>
-                  <a:srgbClr val="4A4F57"/>
-                </a:solidFill>
-                <a:latin typeface="Calibri" pitchFamily="34" charset="0"/>
-                <a:ea typeface="Calibri" pitchFamily="34" charset="-122"/>
-                <a:cs typeface="Calibri" pitchFamily="34" charset="-120"/>
-              </a:rPr>
-              <a:t>confidence shift</a:t>
-            </a:r>
-            <a:endParaRPr lang="en-US" sz="1000" dirty="0"/>
-          </a:p>
-          <a:p>
-            <a:pPr indent="0" marL="0">
-              <a:spcAft>
-                <a:spcPts val="400"/>
-              </a:spcAft>
-              <a:buNone/>
-            </a:pPr>
-            <a:r>
-              <a:rPr lang="en-US" sz="1000" dirty="0">
-                <a:solidFill>
-                  <a:srgbClr val="4A4F57"/>
-                </a:solidFill>
-                <a:latin typeface="Calibri" pitchFamily="34" charset="0"/>
-                <a:ea typeface="Calibri" pitchFamily="34" charset="-122"/>
-                <a:cs typeface="Calibri" pitchFamily="34" charset="-120"/>
-              </a:rPr>
-              <a:t>motif / rule candidate</a:t>
-            </a:r>
-            <a:endParaRPr lang="en-US" sz="1000" dirty="0"/>
-          </a:p>
-        </p:txBody>
-      </p:sp>
-      <p:sp>
-        <p:nvSpPr>
-          <p:cNvPr id="15" name="Shape 13"/>
-          <p:cNvSpPr/>
-          <p:nvPr/>
-        </p:nvSpPr>
-        <p:spPr>
-          <a:xfrm>
-            <a:off x="6080760" y="1627632"/>
-            <a:ext cx="2697480" cy="2926080"/>
-          </a:xfrm>
-          <a:prstGeom prst="rect">
-            <a:avLst/>
-          </a:prstGeom>
-          <a:solidFill>
-            <a:srgbClr val="FFFFFF"/>
-          </a:solidFill>
-          <a:ln w="6350">
-            <a:solidFill>
-              <a:srgbClr val="C9C2B7"/>
-            </a:solidFill>
-            <a:prstDash val="solid"/>
-          </a:ln>
-        </p:spPr>
-      </p:sp>
-      <p:sp>
-        <p:nvSpPr>
-          <p:cNvPr id="16" name="Shape 14"/>
-          <p:cNvSpPr/>
-          <p:nvPr/>
-        </p:nvSpPr>
-        <p:spPr>
-          <a:xfrm>
-            <a:off x="6080760" y="1627632"/>
-            <a:ext cx="73152" cy="2926080"/>
-          </a:xfrm>
-          <a:prstGeom prst="rect">
-            <a:avLst/>
-          </a:prstGeom>
-          <a:solidFill>
-            <a:srgbClr val="3F6B4A"/>
-          </a:solidFill>
-          <a:ln/>
-        </p:spPr>
-      </p:sp>
-      <p:sp>
-        <p:nvSpPr>
-          <p:cNvPr id="17" name="Text 15"/>
-          <p:cNvSpPr/>
-          <p:nvPr/>
-        </p:nvSpPr>
-        <p:spPr>
-          <a:xfrm>
-            <a:off x="6355080" y="1792224"/>
-            <a:ext cx="2331720" cy="292608"/>
-          </a:xfrm>
-          <a:prstGeom prst="rect">
-            <a:avLst/>
-          </a:prstGeom>
-          <a:noFill/>
-          <a:ln/>
-        </p:spPr>
-        <p:txBody>
-          <a:bodyPr wrap="square" lIns="0" tIns="0" rIns="0" bIns="0" rtlCol="0" anchor="ctr"/>
-          <a:lstStyle/>
-          <a:p>
-            <a:pPr indent="0" marL="0">
-              <a:buNone/>
-            </a:pPr>
-            <a:r>
-              <a:rPr lang="en-US" sz="1400" b="1" dirty="0">
-                <a:solidFill>
-                  <a:srgbClr val="1B1D22"/>
-                </a:solidFill>
-                <a:latin typeface="Georgia" pitchFamily="34" charset="0"/>
-                <a:ea typeface="Georgia" pitchFamily="34" charset="-122"/>
-                <a:cs typeface="Georgia" pitchFamily="34" charset="-120"/>
-              </a:rPr>
-              <a:t>Product improves</a:t>
-            </a:r>
-            <a:endParaRPr lang="en-US" sz="1400" dirty="0"/>
-          </a:p>
-        </p:txBody>
-      </p:sp>
-      <p:sp>
-        <p:nvSpPr>
-          <p:cNvPr id="18" name="Text 16"/>
-          <p:cNvSpPr/>
-          <p:nvPr/>
-        </p:nvSpPr>
-        <p:spPr>
-          <a:xfrm>
-            <a:off x="6355080" y="2084832"/>
-            <a:ext cx="2331720" cy="219456"/>
-          </a:xfrm>
-          <a:prstGeom prst="rect">
-            <a:avLst/>
-          </a:prstGeom>
-          <a:noFill/>
-          <a:ln/>
-        </p:spPr>
-        <p:txBody>
-          <a:bodyPr wrap="square" lIns="0" tIns="0" rIns="0" bIns="0" rtlCol="0" anchor="ctr"/>
-          <a:lstStyle/>
-          <a:p>
-            <a:pPr indent="0" marL="0">
-              <a:buNone/>
-            </a:pPr>
-            <a:r>
-              <a:rPr lang="en-US" sz="950" i="1" dirty="0">
-                <a:solidFill>
-                  <a:srgbClr val="4A4F57"/>
-                </a:solidFill>
-                <a:latin typeface="Calibri" pitchFamily="34" charset="0"/>
-                <a:ea typeface="Calibri" pitchFamily="34" charset="-122"/>
-                <a:cs typeface="Calibri" pitchFamily="34" charset="-120"/>
-              </a:rPr>
-              <a:t>every loop iteration</a:t>
-            </a:r>
-            <a:endParaRPr lang="en-US" sz="950" dirty="0"/>
-          </a:p>
-        </p:txBody>
-      </p:sp>
-      <p:sp>
-        <p:nvSpPr>
-          <p:cNvPr id="19" name="Text 17"/>
-          <p:cNvSpPr/>
-          <p:nvPr/>
-        </p:nvSpPr>
-        <p:spPr>
-          <a:xfrm>
-            <a:off x="6355080" y="2359152"/>
-            <a:ext cx="2286000" cy="2103120"/>
-          </a:xfrm>
-          <a:prstGeom prst="rect">
-            <a:avLst/>
-          </a:prstGeom>
-          <a:noFill/>
-          <a:ln/>
-        </p:spPr>
-        <p:txBody>
-          <a:bodyPr wrap="square" lIns="0" tIns="0" rIns="0" bIns="0" rtlCol="0" anchor="t"/>
-          <a:lstStyle/>
-          <a:p>
-            <a:pPr indent="0" marL="0">
-              <a:spcAft>
-                <a:spcPts val="400"/>
-              </a:spcAft>
-              <a:buNone/>
-            </a:pPr>
-            <a:r>
-              <a:rPr lang="en-US" sz="1000" dirty="0">
-                <a:solidFill>
-                  <a:srgbClr val="4A4F57"/>
-                </a:solidFill>
-                <a:latin typeface="Calibri" pitchFamily="34" charset="0"/>
-                <a:ea typeface="Calibri" pitchFamily="34" charset="-122"/>
-                <a:cs typeface="Calibri" pitchFamily="34" charset="-120"/>
-              </a:rPr>
-              <a:t>fewer repeated errors</a:t>
-            </a:r>
-            <a:endParaRPr lang="en-US" sz="1000" dirty="0"/>
-          </a:p>
-          <a:p>
-            <a:pPr indent="0" marL="0">
-              <a:spcAft>
-                <a:spcPts val="400"/>
-              </a:spcAft>
-              <a:buNone/>
-            </a:pPr>
-            <a:r>
-              <a:rPr lang="en-US" sz="1000" dirty="0">
-                <a:solidFill>
-                  <a:srgbClr val="4A4F57"/>
-                </a:solidFill>
-                <a:latin typeface="Calibri" pitchFamily="34" charset="0"/>
-                <a:ea typeface="Calibri" pitchFamily="34" charset="-122"/>
-                <a:cs typeface="Calibri" pitchFamily="34" charset="-120"/>
-              </a:rPr>
-              <a:t>better retrieval</a:t>
-            </a:r>
-            <a:endParaRPr lang="en-US" sz="1000" dirty="0"/>
-          </a:p>
-          <a:p>
-            <a:pPr indent="0" marL="0">
-              <a:spcAft>
-                <a:spcPts val="400"/>
-              </a:spcAft>
-              <a:buNone/>
-            </a:pPr>
-            <a:r>
-              <a:rPr lang="en-US" sz="1000" dirty="0">
-                <a:solidFill>
-                  <a:srgbClr val="4A4F57"/>
-                </a:solidFill>
-                <a:latin typeface="Calibri" pitchFamily="34" charset="0"/>
-                <a:ea typeface="Calibri" pitchFamily="34" charset="-122"/>
-                <a:cs typeface="Calibri" pitchFamily="34" charset="-120"/>
-              </a:rPr>
-              <a:t>tighter conformal bands</a:t>
-            </a:r>
-            <a:endParaRPr lang="en-US" sz="1000" dirty="0"/>
-          </a:p>
-          <a:p>
-            <a:pPr indent="0" marL="0">
-              <a:spcAft>
-                <a:spcPts val="400"/>
-              </a:spcAft>
-              <a:buNone/>
-            </a:pPr>
-            <a:r>
-              <a:rPr lang="en-US" sz="1000" dirty="0">
-                <a:solidFill>
-                  <a:srgbClr val="4A4F57"/>
-                </a:solidFill>
-                <a:latin typeface="Calibri" pitchFamily="34" charset="0"/>
-                <a:ea typeface="Calibri" pitchFamily="34" charset="-122"/>
-                <a:cs typeface="Calibri" pitchFamily="34" charset="-120"/>
-              </a:rPr>
-              <a:t>stronger prototype memory</a:t>
-            </a:r>
-            <a:endParaRPr lang="en-US" sz="1000" dirty="0"/>
-          </a:p>
-          <a:p>
-            <a:pPr indent="0" marL="0">
-              <a:spcAft>
-                <a:spcPts val="400"/>
-              </a:spcAft>
-              <a:buNone/>
-            </a:pPr>
-            <a:r>
-              <a:rPr lang="en-US" sz="1000" dirty="0">
-                <a:solidFill>
-                  <a:srgbClr val="4A4F57"/>
-                </a:solidFill>
-                <a:latin typeface="Calibri" pitchFamily="34" charset="0"/>
-                <a:ea typeface="Calibri" pitchFamily="34" charset="-122"/>
-                <a:cs typeface="Calibri" pitchFamily="34" charset="-120"/>
-              </a:rPr>
-              <a:t>new deterministic rules</a:t>
-            </a:r>
-            <a:endParaRPr lang="en-US" sz="1000" dirty="0"/>
-          </a:p>
-          <a:p>
-            <a:pPr indent="0" marL="0">
-              <a:spcAft>
-                <a:spcPts val="400"/>
-              </a:spcAft>
-              <a:buNone/>
-            </a:pPr>
-            <a:r>
-              <a:rPr lang="en-US" sz="1000" dirty="0">
-                <a:solidFill>
-                  <a:srgbClr val="4A4F57"/>
-                </a:solidFill>
-                <a:latin typeface="Calibri" pitchFamily="34" charset="0"/>
-                <a:ea typeface="Calibri" pitchFamily="34" charset="-122"/>
-                <a:cs typeface="Calibri" pitchFamily="34" charset="-120"/>
-              </a:rPr>
-              <a:t>safer auto-apply threshold</a:t>
-            </a:r>
-            <a:endParaRPr lang="en-US" sz="1000" dirty="0"/>
-          </a:p>
-        </p:txBody>
-      </p:sp>
-      <p:sp>
-        <p:nvSpPr>
-          <p:cNvPr id="20" name="Shape 18"/>
-          <p:cNvSpPr/>
-          <p:nvPr/>
-        </p:nvSpPr>
-        <p:spPr>
-          <a:xfrm>
-            <a:off x="502920" y="4555000"/>
-            <a:ext cx="8229600" cy="291320"/>
-          </a:xfrm>
-          <a:prstGeom prst="rect">
-            <a:avLst/>
-          </a:prstGeom>
-          <a:solidFill>
-            <a:srgbClr val="1B1D22"/>
-          </a:solidFill>
-          <a:ln/>
-        </p:spPr>
-      </p:sp>
-      <p:sp>
-        <p:nvSpPr>
-          <p:cNvPr id="21" name="Text 19"/>
-          <p:cNvSpPr/>
-          <p:nvPr/>
-        </p:nvSpPr>
-        <p:spPr>
-          <a:xfrm>
-            <a:off x="594360" y="4555000"/>
-            <a:ext cx="8046720" cy="291320"/>
-          </a:xfrm>
-          <a:prstGeom prst="rect">
-            <a:avLst/>
-          </a:prstGeom>
-          <a:noFill/>
-          <a:ln/>
-        </p:spPr>
-        <p:txBody>
-          <a:bodyPr wrap="square" lIns="0" tIns="0" rIns="0" bIns="0" rtlCol="0" anchor="ctr"/>
-          <a:lstStyle/>
-          <a:p>
-            <a:pPr indent="0" marL="0">
-              <a:buNone/>
-            </a:pPr>
-            <a:r>
-              <a:rPr lang="en-US" sz="950" b="1" dirty="0">
-                <a:solidFill>
-                  <a:srgbClr val="C8761A"/>
-                </a:solidFill>
-                <a:latin typeface="Calibri" pitchFamily="34" charset="0"/>
-                <a:ea typeface="Calibri" pitchFamily="34" charset="-122"/>
-                <a:cs typeface="Calibri" pitchFamily="34" charset="-120"/>
-              </a:rPr>
-              <a:t xml:space="preserve">Engagement is an ML systems variable:  </a:t>
-            </a:r>
-            <a:pPr indent="0" marL="0">
-              <a:buNone/>
-            </a:pPr>
-            <a:r>
-              <a:rPr lang="en-US" sz="950" i="1" dirty="0">
-                <a:solidFill>
-                  <a:srgbClr val="E9E2D2"/>
-                </a:solidFill>
-                <a:latin typeface="Calibri" pitchFamily="34" charset="0"/>
-                <a:ea typeface="Calibri" pitchFamily="34" charset="-122"/>
-                <a:cs typeface="Calibri" pitchFamily="34" charset="-120"/>
-              </a:rPr>
-              <a:t>better DX creates better labels; better labels create better automation; better automation earns more trust.</a:t>
-            </a:r>
-            <a:endParaRPr lang="en-US" sz="1050" dirty="0"/>
-          </a:p>
-        </p:txBody>
-      </p:sp>
-      <p:sp>
-        <p:nvSpPr>
-          <p:cNvPr id="22" name="Text 20"/>
-          <p:cNvSpPr/>
-          <p:nvPr/>
-        </p:nvSpPr>
-        <p:spPr>
-          <a:xfrm>
-            <a:off x="457200" y="4846320"/>
-            <a:ext cx="5486400" cy="228600"/>
-          </a:xfrm>
-          <a:prstGeom prst="rect">
-            <a:avLst/>
-          </a:prstGeom>
-          <a:noFill/>
-          <a:ln/>
-        </p:spPr>
-        <p:txBody>
-          <a:bodyPr wrap="square" lIns="0" tIns="0" rIns="0" bIns="0" rtlCol="0" anchor="ctr"/>
-          <a:lstStyle/>
-          <a:p>
-            <a:pPr indent="0" marL="0">
-              <a:buNone/>
-            </a:pPr>
-            <a:r>
-              <a:rPr lang="en-US" sz="900" dirty="0">
-                <a:solidFill>
-                  <a:srgbClr val="4A4F57"/>
-                </a:solidFill>
-                <a:latin typeface="Calibri" pitchFamily="34" charset="0"/>
-                <a:ea typeface="Calibri" pitchFamily="34" charset="-122"/>
-                <a:cs typeface="Calibri" pitchFamily="34" charset="-120"/>
-              </a:rPr>
-              <a:t>Augrade · GNN strategy · M. Mabie</a:t>
-            </a:r>
-            <a:endParaRPr lang="en-US" sz="900" dirty="0"/>
-          </a:p>
-        </p:txBody>
-      </p:sp>
-      <p:sp>
-        <p:nvSpPr>
-          <p:cNvPr id="23" name="Text 21"/>
-          <p:cNvSpPr/>
-          <p:nvPr/>
-        </p:nvSpPr>
-        <p:spPr>
-          <a:xfrm>
-            <a:off x="8229600" y="4846320"/>
-            <a:ext cx="731520" cy="228600"/>
-          </a:xfrm>
-          <a:prstGeom prst="rect">
-            <a:avLst/>
-          </a:prstGeom>
-          <a:noFill/>
-          <a:ln/>
-        </p:spPr>
-        <p:txBody>
-          <a:bodyPr wrap="square" lIns="0" tIns="0" rIns="0" bIns="0" rtlCol="0" anchor="ctr"/>
-          <a:lstStyle/>
-          <a:p>
-            <a:pPr algn="r" indent="0" marL="0">
-              <a:buNone/>
-            </a:pPr>
-            <a:r>
-              <a:rPr lang="en-US" sz="900" dirty="0">
-                <a:solidFill>
-                  <a:srgbClr val="4A4F57"/>
-                </a:solidFill>
-                <a:latin typeface="Calibri" pitchFamily="34" charset="0"/>
-                <a:ea typeface="Calibri" pitchFamily="34" charset="-122"/>
-                <a:cs typeface="Calibri" pitchFamily="34" charset="-120"/>
-              </a:rPr>
-              <a:t>12 / 18</a:t>
+              <a:t>DXF_Primitive_to_Polygon · gnn_plan/</a:t>
             </a:r>
             <a:endParaRPr lang="en-US" sz="900" dirty="0"/>
           </a:p>
@@ -12527,6 +12915,10 @@
             <a:prstDash val="solid"/>
           </a:ln>
         </p:spPr>
+        <p:txBody>
+          <a:bodyPr/>
+          <a:p/>
+        </p:txBody>
       </p:sp>
       <p:sp>
         <p:nvSpPr>
@@ -12591,6 +12983,10 @@
             <a:prstDash val="solid"/>
           </a:ln>
         </p:spPr>
+        <p:txBody>
+          <a:bodyPr/>
+          <a:p/>
+        </p:txBody>
       </p:sp>
       <p:sp>
         <p:nvSpPr>
@@ -12611,6 +13007,10 @@
           </a:solidFill>
           <a:ln/>
         </p:spPr>
+        <p:txBody>
+          <a:bodyPr/>
+          <a:p/>
+        </p:txBody>
       </p:sp>
       <p:pic>
         <p:nvPicPr>
@@ -12738,6 +13138,10 @@
             <a:prstDash val="solid"/>
           </a:ln>
         </p:spPr>
+        <p:txBody>
+          <a:bodyPr/>
+          <a:p/>
+        </p:txBody>
       </p:sp>
       <p:sp>
         <p:nvSpPr>
@@ -12758,6 +13162,10 @@
           </a:solidFill>
           <a:ln/>
         </p:spPr>
+        <p:txBody>
+          <a:bodyPr/>
+          <a:p/>
+        </p:txBody>
       </p:sp>
       <p:pic>
         <p:nvPicPr>
@@ -12885,6 +13293,10 @@
             <a:prstDash val="solid"/>
           </a:ln>
         </p:spPr>
+        <p:txBody>
+          <a:bodyPr/>
+          <a:p/>
+        </p:txBody>
       </p:sp>
       <p:sp>
         <p:nvSpPr>
@@ -12905,6 +13317,10 @@
           </a:solidFill>
           <a:ln/>
         </p:spPr>
+        <p:txBody>
+          <a:bodyPr/>
+          <a:p/>
+        </p:txBody>
       </p:sp>
       <p:pic>
         <p:nvPicPr>
@@ -13179,6 +13595,10 @@
             <a:prstDash val="solid"/>
           </a:ln>
         </p:spPr>
+        <p:txBody>
+          <a:bodyPr/>
+          <a:p/>
+        </p:txBody>
       </p:sp>
       <p:sp>
         <p:nvSpPr>
@@ -13238,6 +13658,10 @@
           </a:solidFill>
           <a:ln/>
         </p:spPr>
+        <p:txBody>
+          <a:bodyPr/>
+          <a:p/>
+        </p:txBody>
       </p:sp>
       <p:sp>
         <p:nvSpPr>
@@ -13258,6 +13682,10 @@
           </a:solidFill>
           <a:ln/>
         </p:spPr>
+        <p:txBody>
+          <a:bodyPr/>
+          <a:p/>
+        </p:txBody>
       </p:sp>
       <p:sp>
         <p:nvSpPr>
@@ -13424,6 +13852,10 @@
             <a:prstDash val="solid"/>
           </a:ln>
         </p:spPr>
+        <p:txBody>
+          <a:bodyPr/>
+          <a:p/>
+        </p:txBody>
       </p:sp>
       <p:sp>
         <p:nvSpPr>
@@ -13444,6 +13876,10 @@
           </a:solidFill>
           <a:ln/>
         </p:spPr>
+        <p:txBody>
+          <a:bodyPr/>
+          <a:p/>
+        </p:txBody>
       </p:sp>
       <p:sp>
         <p:nvSpPr>
@@ -13561,6 +13997,10 @@
             <a:prstDash val="solid"/>
           </a:ln>
         </p:spPr>
+        <p:txBody>
+          <a:bodyPr/>
+          <a:p/>
+        </p:txBody>
       </p:sp>
       <p:sp>
         <p:nvSpPr>
@@ -13581,6 +14021,10 @@
           </a:solidFill>
           <a:ln/>
         </p:spPr>
+        <p:txBody>
+          <a:bodyPr/>
+          <a:p/>
+        </p:txBody>
       </p:sp>
       <p:sp>
         <p:nvSpPr>
@@ -13737,6 +14181,10 @@
             <a:prstDash val="solid"/>
           </a:ln>
         </p:spPr>
+        <p:txBody>
+          <a:bodyPr/>
+          <a:p/>
+        </p:txBody>
       </p:sp>
       <p:sp>
         <p:nvSpPr>
@@ -13799,6 +14247,10 @@
             <a:prstDash val="solid"/>
           </a:ln>
         </p:spPr>
+        <p:txBody>
+          <a:bodyPr/>
+          <a:p/>
+        </p:txBody>
       </p:sp>
       <p:sp>
         <p:nvSpPr>
@@ -13824,6 +14276,10 @@
             <a:prstDash val="solid"/>
           </a:ln>
         </p:spPr>
+        <p:txBody>
+          <a:bodyPr/>
+          <a:p/>
+        </p:txBody>
       </p:sp>
       <p:sp>
         <p:nvSpPr>
@@ -13886,6 +14342,10 @@
             <a:prstDash val="solid"/>
           </a:ln>
         </p:spPr>
+        <p:txBody>
+          <a:bodyPr/>
+          <a:p/>
+        </p:txBody>
       </p:sp>
       <p:sp>
         <p:nvSpPr>
@@ -13911,6 +14371,10 @@
             <a:prstDash val="solid"/>
           </a:ln>
         </p:spPr>
+        <p:txBody>
+          <a:bodyPr/>
+          <a:p/>
+        </p:txBody>
       </p:sp>
       <p:sp>
         <p:nvSpPr>
@@ -13973,6 +14437,10 @@
             <a:prstDash val="solid"/>
           </a:ln>
         </p:spPr>
+        <p:txBody>
+          <a:bodyPr/>
+          <a:p/>
+        </p:txBody>
       </p:sp>
       <p:sp>
         <p:nvSpPr>
@@ -13998,6 +14466,10 @@
             <a:prstDash val="solid"/>
           </a:ln>
         </p:spPr>
+        <p:txBody>
+          <a:bodyPr/>
+          <a:p/>
+        </p:txBody>
       </p:sp>
       <p:sp>
         <p:nvSpPr>
@@ -14060,6 +14532,10 @@
             <a:prstDash val="solid"/>
           </a:ln>
         </p:spPr>
+        <p:txBody>
+          <a:bodyPr/>
+          <a:p/>
+        </p:txBody>
       </p:sp>
       <p:sp>
         <p:nvSpPr>
@@ -14085,6 +14561,10 @@
             <a:prstDash val="solid"/>
           </a:ln>
         </p:spPr>
+        <p:txBody>
+          <a:bodyPr/>
+          <a:p/>
+        </p:txBody>
       </p:sp>
       <p:sp>
         <p:nvSpPr>
@@ -14335,6 +14815,10 @@
             <a:prstDash val="solid"/>
           </a:ln>
         </p:spPr>
+        <p:txBody>
+          <a:bodyPr/>
+          <a:p/>
+        </p:txBody>
       </p:sp>
       <p:sp>
         <p:nvSpPr>
@@ -14399,6 +14883,10 @@
             <a:prstDash val="solid"/>
           </a:ln>
         </p:spPr>
+        <p:txBody>
+          <a:bodyPr/>
+          <a:p/>
+        </p:txBody>
       </p:sp>
       <p:sp>
         <p:nvSpPr>
@@ -14419,6 +14907,10 @@
           </a:solidFill>
           <a:ln/>
         </p:spPr>
+        <p:txBody>
+          <a:bodyPr/>
+          <a:p/>
+        </p:txBody>
       </p:sp>
       <p:sp>
         <p:nvSpPr>
@@ -14561,6 +15053,10 @@
             <a:prstDash val="solid"/>
           </a:ln>
         </p:spPr>
+        <p:txBody>
+          <a:bodyPr/>
+          <a:p/>
+        </p:txBody>
       </p:sp>
       <p:sp>
         <p:nvSpPr>
@@ -14581,6 +15077,10 @@
           </a:solidFill>
           <a:ln/>
         </p:spPr>
+        <p:txBody>
+          <a:bodyPr/>
+          <a:p/>
+        </p:txBody>
       </p:sp>
       <p:sp>
         <p:nvSpPr>
@@ -14723,6 +15223,10 @@
             <a:prstDash val="solid"/>
           </a:ln>
         </p:spPr>
+        <p:txBody>
+          <a:bodyPr/>
+          <a:p/>
+        </p:txBody>
       </p:sp>
       <p:sp>
         <p:nvSpPr>
@@ -14743,6 +15247,10 @@
           </a:solidFill>
           <a:ln/>
         </p:spPr>
+        <p:txBody>
+          <a:bodyPr/>
+          <a:p/>
+        </p:txBody>
       </p:sp>
       <p:sp>
         <p:nvSpPr>
@@ -14885,6 +15393,10 @@
             <a:prstDash val="solid"/>
           </a:ln>
         </p:spPr>
+        <p:txBody>
+          <a:bodyPr/>
+          <a:p/>
+        </p:txBody>
       </p:sp>
       <p:sp>
         <p:nvSpPr>
@@ -14905,6 +15417,10 @@
           </a:solidFill>
           <a:ln/>
         </p:spPr>
+        <p:txBody>
+          <a:bodyPr/>
+          <a:p/>
+        </p:txBody>
       </p:sp>
       <p:sp>
         <p:nvSpPr>
@@ -15047,6 +15563,10 @@
             <a:prstDash val="solid"/>
           </a:ln>
         </p:spPr>
+        <p:txBody>
+          <a:bodyPr/>
+          <a:p/>
+        </p:txBody>
       </p:sp>
       <p:sp>
         <p:nvSpPr>
@@ -15067,6 +15587,10 @@
           </a:solidFill>
           <a:ln/>
         </p:spPr>
+        <p:txBody>
+          <a:bodyPr/>
+          <a:p/>
+        </p:txBody>
       </p:sp>
       <p:sp>
         <p:nvSpPr>
@@ -15209,6 +15733,10 @@
             <a:prstDash val="solid"/>
           </a:ln>
         </p:spPr>
+        <p:txBody>
+          <a:bodyPr/>
+          <a:p/>
+        </p:txBody>
       </p:sp>
       <p:sp>
         <p:nvSpPr>
@@ -15229,6 +15757,10 @@
           </a:solidFill>
           <a:ln/>
         </p:spPr>
+        <p:txBody>
+          <a:bodyPr/>
+          <a:p/>
+        </p:txBody>
       </p:sp>
       <p:sp>
         <p:nvSpPr>
@@ -15371,6 +15903,10 @@
             <a:prstDash val="solid"/>
           </a:ln>
         </p:spPr>
+        <p:txBody>
+          <a:bodyPr/>
+          <a:p/>
+        </p:txBody>
       </p:sp>
       <p:sp>
         <p:nvSpPr>
@@ -15391,6 +15927,10 @@
           </a:solidFill>
           <a:ln/>
         </p:spPr>
+        <p:txBody>
+          <a:bodyPr/>
+          <a:p/>
+        </p:txBody>
       </p:sp>
       <p:sp>
         <p:nvSpPr>
@@ -15533,6 +16073,10 @@
             <a:prstDash val="solid"/>
           </a:ln>
         </p:spPr>
+        <p:txBody>
+          <a:bodyPr/>
+          <a:p/>
+        </p:txBody>
       </p:sp>
       <p:sp>
         <p:nvSpPr>
@@ -15553,6 +16097,10 @@
           </a:solidFill>
           <a:ln/>
         </p:spPr>
+        <p:txBody>
+          <a:bodyPr/>
+          <a:p/>
+        </p:txBody>
       </p:sp>
       <p:sp>
         <p:nvSpPr>
@@ -15749,6 +16297,10 @@
             <a:prstDash val="solid"/>
           </a:ln>
         </p:spPr>
+        <p:txBody>
+          <a:bodyPr/>
+          <a:p/>
+        </p:txBody>
       </p:sp>
       <p:sp>
         <p:nvSpPr>
@@ -15828,6 +16380,10 @@
             <a:prstDash val="solid"/>
           </a:ln>
         </p:spPr>
+        <p:txBody>
+          <a:bodyPr/>
+          <a:p/>
+        </p:txBody>
       </p:sp>
       <p:sp>
         <p:nvSpPr>
@@ -16041,6 +16597,10 @@
             <a:prstDash val="solid"/>
           </a:ln>
         </p:spPr>
+        <p:txBody>
+          <a:bodyPr/>
+          <a:p/>
+        </p:txBody>
       </p:sp>
       <p:sp>
         <p:nvSpPr>
@@ -16252,6 +16812,10 @@
             <a:prstDash val="solid"/>
           </a:ln>
         </p:spPr>
+        <p:txBody>
+          <a:bodyPr/>
+          <a:p/>
+        </p:txBody>
       </p:sp>
       <p:sp>
         <p:nvSpPr>
@@ -16691,6 +17255,10 @@
           </a:solidFill>
           <a:ln/>
         </p:spPr>
+        <p:txBody>
+          <a:bodyPr/>
+          <a:p/>
+        </p:txBody>
       </p:sp>
       <p:sp>
         <p:nvSpPr>
@@ -16916,6 +17484,10 @@
             <a:prstDash val="solid"/>
           </a:ln>
         </p:spPr>
+        <p:txBody>
+          <a:bodyPr/>
+          <a:p/>
+        </p:txBody>
       </p:sp>
       <p:sp>
         <p:nvSpPr>
@@ -16984,6 +17556,10 @@
             <a:prstDash val="solid"/>
           </a:ln>
         </p:spPr>
+        <p:txBody>
+          <a:bodyPr/>
+          <a:p/>
+        </p:txBody>
       </p:sp>
       <p:sp>
         <p:nvSpPr>
@@ -17069,6 +17645,10 @@
             <a:prstDash val="solid"/>
           </a:ln>
         </p:spPr>
+        <p:txBody>
+          <a:bodyPr/>
+          <a:p/>
+        </p:txBody>
       </p:sp>
       <p:sp>
         <p:nvSpPr>
@@ -17154,6 +17734,10 @@
             <a:prstDash val="solid"/>
           </a:ln>
         </p:spPr>
+        <p:txBody>
+          <a:bodyPr/>
+          <a:p/>
+        </p:txBody>
       </p:sp>
       <p:sp>
         <p:nvSpPr>
@@ -17239,6 +17823,10 @@
             <a:prstDash val="solid"/>
           </a:ln>
         </p:spPr>
+        <p:txBody>
+          <a:bodyPr/>
+          <a:p/>
+        </p:txBody>
       </p:sp>
       <p:sp>
         <p:nvSpPr>
@@ -17324,6 +17912,10 @@
             <a:prstDash val="solid"/>
           </a:ln>
         </p:spPr>
+        <p:txBody>
+          <a:bodyPr/>
+          <a:p/>
+        </p:txBody>
       </p:sp>
       <p:sp>
         <p:nvSpPr>
@@ -17726,6 +18318,10 @@
             <a:prstDash val="solid"/>
           </a:ln>
         </p:spPr>
+        <p:txBody>
+          <a:bodyPr/>
+          <a:p/>
+        </p:txBody>
       </p:sp>
       <p:sp>
         <p:nvSpPr>
@@ -17983,6 +18579,10 @@
             <a:prstDash val="solid"/>
           </a:ln>
         </p:spPr>
+        <p:txBody>
+          <a:bodyPr/>
+          <a:p/>
+        </p:txBody>
       </p:sp>
       <p:sp>
         <p:nvSpPr>
@@ -18003,6 +18603,10 @@
           </a:solidFill>
           <a:ln/>
         </p:spPr>
+        <p:txBody>
+          <a:bodyPr/>
+          <a:p/>
+        </p:txBody>
       </p:sp>
       <p:sp>
         <p:nvSpPr>
@@ -18218,6 +18822,10 @@
           </a:solidFill>
           <a:ln/>
         </p:spPr>
+        <p:txBody>
+          <a:bodyPr/>
+          <a:p/>
+        </p:txBody>
       </p:sp>
       <p:sp>
         <p:nvSpPr>
@@ -18433,6 +19041,10 @@
           </a:solidFill>
           <a:ln/>
         </p:spPr>
+        <p:txBody>
+          <a:bodyPr/>
+          <a:p/>
+        </p:txBody>
       </p:sp>
       <p:sp>
         <p:nvSpPr>
@@ -18648,6 +19260,10 @@
           </a:solidFill>
           <a:ln/>
         </p:spPr>
+        <p:txBody>
+          <a:bodyPr/>
+          <a:p/>
+        </p:txBody>
       </p:sp>
       <p:sp>
         <p:nvSpPr>
@@ -18863,6 +19479,10 @@
           </a:solidFill>
           <a:ln/>
         </p:spPr>
+        <p:txBody>
+          <a:bodyPr/>
+          <a:p/>
+        </p:txBody>
       </p:sp>
       <p:sp>
         <p:nvSpPr>
@@ -19078,6 +19698,10 @@
           </a:solidFill>
           <a:ln/>
         </p:spPr>
+        <p:txBody>
+          <a:bodyPr/>
+          <a:p/>
+        </p:txBody>
       </p:sp>
       <p:sp>
         <p:nvSpPr>
@@ -19445,6 +20069,10 @@
             <a:prstDash val="solid"/>
           </a:ln>
         </p:spPr>
+        <p:txBody>
+          <a:bodyPr/>
+          <a:p/>
+        </p:txBody>
       </p:sp>
       <p:sp>
         <p:nvSpPr>
@@ -19509,6 +20137,10 @@
             <a:prstDash val="solid"/>
           </a:ln>
         </p:spPr>
+        <p:txBody>
+          <a:bodyPr/>
+          <a:p/>
+        </p:txBody>
       </p:sp>
       <p:sp>
         <p:nvSpPr>
@@ -19651,6 +20283,10 @@
             <a:prstDash val="solid"/>
           </a:ln>
         </p:spPr>
+        <p:txBody>
+          <a:bodyPr/>
+          <a:p/>
+        </p:txBody>
       </p:sp>
       <p:sp>
         <p:nvSpPr>
@@ -19793,6 +20429,10 @@
             <a:prstDash val="solid"/>
           </a:ln>
         </p:spPr>
+        <p:txBody>
+          <a:bodyPr/>
+          <a:p/>
+        </p:txBody>
       </p:sp>
       <p:sp>
         <p:nvSpPr>
@@ -19935,6 +20575,10 @@
             <a:prstDash val="solid"/>
           </a:ln>
         </p:spPr>
+        <p:txBody>
+          <a:bodyPr/>
+          <a:p/>
+        </p:txBody>
       </p:sp>
       <p:sp>
         <p:nvSpPr>
@@ -20077,6 +20721,10 @@
             <a:prstDash val="solid"/>
           </a:ln>
         </p:spPr>
+        <p:txBody>
+          <a:bodyPr/>
+          <a:p/>
+        </p:txBody>
       </p:sp>
       <p:sp>
         <p:nvSpPr>
@@ -20219,6 +20867,10 @@
             <a:prstDash val="solid"/>
           </a:ln>
         </p:spPr>
+        <p:txBody>
+          <a:bodyPr/>
+          <a:p/>
+        </p:txBody>
       </p:sp>
       <p:sp>
         <p:nvSpPr>
@@ -20508,6 +21160,10 @@
             <a:prstDash val="solid"/>
           </a:ln>
         </p:spPr>
+        <p:txBody>
+          <a:bodyPr/>
+          <a:p/>
+        </p:txBody>
       </p:sp>
       <p:sp>
         <p:nvSpPr>
@@ -20572,6 +21228,10 @@
             <a:prstDash val="solid"/>
           </a:ln>
         </p:spPr>
+        <p:txBody>
+          <a:bodyPr/>
+          <a:p/>
+        </p:txBody>
       </p:sp>
       <p:sp>
         <p:nvSpPr>
@@ -20592,6 +21252,10 @@
           </a:solidFill>
           <a:ln/>
         </p:spPr>
+        <p:txBody>
+          <a:bodyPr/>
+          <a:p/>
+        </p:txBody>
       </p:sp>
       <p:sp>
         <p:nvSpPr>
@@ -20838,6 +21502,10 @@
             <a:prstDash val="solid"/>
           </a:ln>
         </p:spPr>
+        <p:txBody>
+          <a:bodyPr/>
+          <a:p/>
+        </p:txBody>
       </p:sp>
       <p:sp>
         <p:nvSpPr>
@@ -20858,6 +21526,10 @@
           </a:solidFill>
           <a:ln/>
         </p:spPr>
+        <p:txBody>
+          <a:bodyPr/>
+          <a:p/>
+        </p:txBody>
       </p:sp>
       <p:sp>
         <p:nvSpPr>

</xml_diff>